<commit_message>
Prezentacja światło v2: bez namiotu, obiad 13:00, rysunki na każdym slajdzie
Co-Authored-By: Claude Sonnet 5.5 <noreply@anthropic.com>
Claude-Session: https://claude.ai/code/session_01RxET8S5NWKo13oo2mh7L1U
</commit_message>
<xml_diff>
--- a/projekty/warsztaty-beauty-product/swiatlo-jako-narzedzie-pracy-v2.pptx
+++ b/projekty/warsztaty-beauty-product/swiatlo-jako-narzedzie-pracy-v2.pptx
@@ -25,14 +25,13 @@
     <p:sldId id="267" r:id="rId15"/>
     <p:sldId id="268" r:id="rId16"/>
     <p:sldId id="264" r:id="rId17"/>
-    <p:sldId id="277" r:id="rId35"/>
     <p:sldId id="265" r:id="rId18"/>
     <p:sldId id="270" r:id="rId19"/>
     <p:sldId id="271" r:id="rId20"/>
     <p:sldId id="272" r:id="rId21"/>
     <p:sldId id="273" r:id="rId22"/>
     <p:sldId id="274" r:id="rId23"/>
-    <p:sldId id="278" r:id="rId36"/>
+    <p:sldId id="277" r:id="rId35"/>
     <p:sldId id="275" r:id="rId24"/>
   </p:sldIdLst>
   <p:sldSz cx="12192000" cy="6858000"/>
@@ -17571,6 +17570,368 @@
           </a:p>
         </p:txBody>
       </p:sp>
+      <p:sp>
+        <p:nvSpPr>
+          <p:cNvPr id="101" name="Element 101"/>
+          <p:cNvSpPr/>
+          <p:nvPr/>
+        </p:nvSpPr>
+        <p:spPr>
+          <a:xfrm rot="16200000">
+            <a:off x="6217920" y="2331720"/>
+            <a:ext cx="1463040" cy="1005840"/>
+          </a:xfrm>
+          <a:prstGeom prst="trapezoid">
+            <a:avLst/>
+          </a:prstGeom>
+          <a:noFill/>
+          <a:ln w="22225">
+            <a:solidFill>
+              <a:srgbClr val="404040"/>
+            </a:solidFill>
+          </a:ln>
+        </p:spPr>
+        <p:txBody>
+          <a:bodyPr/>
+          <a:lstStyle/>
+          <a:p>
+            <a:endParaRPr lang="pl-PL"/>
+          </a:p>
+        </p:txBody>
+      </p:sp>
+      <p:cxnSp>
+        <p:nvCxnSpPr>
+          <p:cNvPr id="102" name="Linia 102"/>
+          <p:cNvCxnSpPr/>
+          <p:nvPr/>
+        </p:nvCxnSpPr>
+        <p:spPr>
+          <a:xfrm flipV="1">
+            <a:off x="7498080" y="1828800"/>
+            <a:ext cx="1554480" cy="653796"/>
+          </a:xfrm>
+          <a:prstGeom prst="line">
+            <a:avLst/>
+          </a:prstGeom>
+          <a:ln w="15875">
+            <a:solidFill>
+              <a:srgbClr val="E3B18D"/>
+            </a:solidFill>
+            <a:prstDash val="dash"/>
+          </a:ln>
+        </p:spPr>
+      </p:cxnSp>
+      <p:cxnSp>
+        <p:nvCxnSpPr>
+          <p:cNvPr id="103" name="Linia 103"/>
+          <p:cNvCxnSpPr/>
+          <p:nvPr/>
+        </p:nvCxnSpPr>
+        <p:spPr>
+          <a:xfrm flipV="1">
+            <a:off x="7498080" y="2377440"/>
+            <a:ext cx="1554480" cy="297180"/>
+          </a:xfrm>
+          <a:prstGeom prst="line">
+            <a:avLst/>
+          </a:prstGeom>
+          <a:ln w="15875">
+            <a:solidFill>
+              <a:srgbClr val="E3B18D"/>
+            </a:solidFill>
+            <a:prstDash val="dash"/>
+          </a:ln>
+        </p:spPr>
+      </p:cxnSp>
+      <p:cxnSp>
+        <p:nvCxnSpPr>
+          <p:cNvPr id="104" name="Linia 104"/>
+          <p:cNvCxnSpPr/>
+          <p:nvPr/>
+        </p:nvCxnSpPr>
+        <p:spPr>
+          <a:xfrm>
+            <a:off x="7498080" y="2834640"/>
+            <a:ext cx="1554480" cy="0"/>
+          </a:xfrm>
+          <a:prstGeom prst="line">
+            <a:avLst/>
+          </a:prstGeom>
+          <a:ln w="15875">
+            <a:solidFill>
+              <a:srgbClr val="E3B18D"/>
+            </a:solidFill>
+            <a:prstDash val="dash"/>
+          </a:ln>
+        </p:spPr>
+      </p:cxnSp>
+      <p:cxnSp>
+        <p:nvCxnSpPr>
+          <p:cNvPr id="105" name="Linia 105"/>
+          <p:cNvCxnSpPr/>
+          <p:nvPr/>
+        </p:nvCxnSpPr>
+        <p:spPr>
+          <a:xfrm>
+            <a:off x="7498080" y="2994660"/>
+            <a:ext cx="1554480" cy="297180"/>
+          </a:xfrm>
+          <a:prstGeom prst="line">
+            <a:avLst/>
+          </a:prstGeom>
+          <a:ln w="15875">
+            <a:solidFill>
+              <a:srgbClr val="E3B18D"/>
+            </a:solidFill>
+            <a:prstDash val="dash"/>
+          </a:ln>
+        </p:spPr>
+      </p:cxnSp>
+      <p:cxnSp>
+        <p:nvCxnSpPr>
+          <p:cNvPr id="106" name="Linia 106"/>
+          <p:cNvCxnSpPr/>
+          <p:nvPr/>
+        </p:nvCxnSpPr>
+        <p:spPr>
+          <a:xfrm>
+            <a:off x="7498080" y="3186684"/>
+            <a:ext cx="1554480" cy="653796"/>
+          </a:xfrm>
+          <a:prstGeom prst="line">
+            <a:avLst/>
+          </a:prstGeom>
+          <a:ln w="15875">
+            <a:solidFill>
+              <a:srgbClr val="E3B18D"/>
+            </a:solidFill>
+            <a:prstDash val="dash"/>
+          </a:ln>
+        </p:spPr>
+      </p:cxnSp>
+      <p:sp>
+        <p:nvSpPr>
+          <p:cNvPr id="107" name="Element 107"/>
+          <p:cNvSpPr/>
+          <p:nvPr/>
+        </p:nvSpPr>
+        <p:spPr>
+          <a:xfrm>
+            <a:off x="6217920" y="4114800"/>
+            <a:ext cx="1828800" cy="365760"/>
+          </a:xfrm>
+          <a:prstGeom prst="rect">
+            <a:avLst/>
+          </a:prstGeom>
+          <a:noFill/>
+          <a:ln>
+            <a:noFill/>
+          </a:ln>
+        </p:spPr>
+        <p:txBody>
+          <a:bodyPr wrap="square" lIns="0" tIns="0" rIns="0" bIns="0" anchor="ctr">
+            <a:noAutofit/>
+          </a:bodyPr>
+          <a:lstStyle/>
+          <a:p>
+            <a:pPr algn="ctr"/>
+            <a:r>
+              <a:rPr lang="pl-PL" sz="1600" b="0" dirty="0">
+                <a:solidFill>
+                  <a:srgbClr val="8A8A8A"/>
+                </a:solidFill>
+                <a:latin typeface="+mn-lt"/>
+              </a:rPr>
+              <a:t>softbox, oct</a:t>
+            </a:r>
+          </a:p>
+        </p:txBody>
+      </p:sp>
+      <p:sp>
+        <p:nvSpPr>
+          <p:cNvPr id="108" name="Element 108"/>
+          <p:cNvSpPr/>
+          <p:nvPr/>
+        </p:nvSpPr>
+        <p:spPr>
+          <a:xfrm>
+            <a:off x="9400032" y="2633472"/>
+            <a:ext cx="402336" cy="402336"/>
+          </a:xfrm>
+          <a:prstGeom prst="ellipse">
+            <a:avLst/>
+          </a:prstGeom>
+          <a:solidFill>
+            <a:srgbClr val="404040"/>
+          </a:solidFill>
+          <a:ln>
+            <a:noFill/>
+          </a:ln>
+        </p:spPr>
+        <p:txBody>
+          <a:bodyPr/>
+          <a:lstStyle/>
+          <a:p>
+            <a:endParaRPr lang="pl-PL"/>
+          </a:p>
+        </p:txBody>
+      </p:sp>
+      <p:cxnSp>
+        <p:nvCxnSpPr>
+          <p:cNvPr id="109" name="Linia 109"/>
+          <p:cNvCxnSpPr/>
+          <p:nvPr/>
+        </p:nvCxnSpPr>
+        <p:spPr>
+          <a:xfrm flipV="1">
+            <a:off x="9784080" y="2560320"/>
+            <a:ext cx="1737360" cy="182880"/>
+          </a:xfrm>
+          <a:prstGeom prst="line">
+            <a:avLst/>
+          </a:prstGeom>
+          <a:ln w="19050">
+            <a:solidFill>
+              <a:srgbClr val="E3B18D"/>
+            </a:solidFill>
+          </a:ln>
+        </p:spPr>
+      </p:cxnSp>
+      <p:cxnSp>
+        <p:nvCxnSpPr>
+          <p:cNvPr id="110" name="Linia 110"/>
+          <p:cNvCxnSpPr/>
+          <p:nvPr/>
+        </p:nvCxnSpPr>
+        <p:spPr>
+          <a:xfrm>
+            <a:off x="9784080" y="2926080"/>
+            <a:ext cx="1737360" cy="182880"/>
+          </a:xfrm>
+          <a:prstGeom prst="line">
+            <a:avLst/>
+          </a:prstGeom>
+          <a:ln w="19050">
+            <a:solidFill>
+              <a:srgbClr val="E3B18D"/>
+            </a:solidFill>
+          </a:ln>
+        </p:spPr>
+      </p:cxnSp>
+      <p:sp>
+        <p:nvSpPr>
+          <p:cNvPr id="111" name="Element 111"/>
+          <p:cNvSpPr/>
+          <p:nvPr/>
+        </p:nvSpPr>
+        <p:spPr>
+          <a:xfrm>
+            <a:off x="9144000" y="4114800"/>
+            <a:ext cx="2377440" cy="365760"/>
+          </a:xfrm>
+          <a:prstGeom prst="rect">
+            <a:avLst/>
+          </a:prstGeom>
+          <a:noFill/>
+          <a:ln>
+            <a:noFill/>
+          </a:ln>
+        </p:spPr>
+        <p:txBody>
+          <a:bodyPr wrap="square" lIns="0" tIns="0" rIns="0" bIns="0" anchor="ctr">
+            <a:noAutofit/>
+          </a:bodyPr>
+          <a:lstStyle/>
+          <a:p>
+            <a:pPr algn="ctr"/>
+            <a:r>
+              <a:rPr lang="pl-PL" sz="1600" b="0" dirty="0">
+                <a:solidFill>
+                  <a:srgbClr val="8A8A8A"/>
+                </a:solidFill>
+                <a:latin typeface="+mn-lt"/>
+              </a:rPr>
+              <a:t>fresnel, spot</a:t>
+            </a:r>
+          </a:p>
+        </p:txBody>
+      </p:sp>
+      <p:sp>
+        <p:nvSpPr>
+          <p:cNvPr id="112" name="Element 112"/>
+          <p:cNvSpPr/>
+          <p:nvPr/>
+        </p:nvSpPr>
+        <p:spPr>
+          <a:xfrm>
+            <a:off x="6217920" y="1463040"/>
+            <a:ext cx="2377440" cy="365760"/>
+          </a:xfrm>
+          <a:prstGeom prst="rect">
+            <a:avLst/>
+          </a:prstGeom>
+          <a:noFill/>
+          <a:ln>
+            <a:noFill/>
+          </a:ln>
+        </p:spPr>
+        <p:txBody>
+          <a:bodyPr wrap="square" lIns="0" tIns="0" rIns="0" bIns="0" anchor="ctr">
+            <a:noAutofit/>
+          </a:bodyPr>
+          <a:lstStyle/>
+          <a:p>
+            <a:pPr algn="l"/>
+            <a:r>
+              <a:rPr lang="pl-PL" sz="1800" b="1" dirty="0">
+                <a:solidFill>
+                  <a:srgbClr val="404040"/>
+                </a:solidFill>
+                <a:latin typeface="+mn-lt"/>
+              </a:rPr>
+              <a:t>miękko</a:t>
+            </a:r>
+          </a:p>
+        </p:txBody>
+      </p:sp>
+      <p:sp>
+        <p:nvSpPr>
+          <p:cNvPr id="113" name="Element 113"/>
+          <p:cNvSpPr/>
+          <p:nvPr/>
+        </p:nvSpPr>
+        <p:spPr>
+          <a:xfrm>
+            <a:off x="9144000" y="1463040"/>
+            <a:ext cx="2377440" cy="365760"/>
+          </a:xfrm>
+          <a:prstGeom prst="rect">
+            <a:avLst/>
+          </a:prstGeom>
+          <a:noFill/>
+          <a:ln>
+            <a:noFill/>
+          </a:ln>
+        </p:spPr>
+        <p:txBody>
+          <a:bodyPr wrap="square" lIns="0" tIns="0" rIns="0" bIns="0" anchor="ctr">
+            <a:noAutofit/>
+          </a:bodyPr>
+          <a:lstStyle/>
+          <a:p>
+            <a:pPr algn="l"/>
+            <a:r>
+              <a:rPr lang="pl-PL" sz="1800" b="1" dirty="0">
+                <a:solidFill>
+                  <a:srgbClr val="404040"/>
+                </a:solidFill>
+                <a:latin typeface="+mn-lt"/>
+              </a:rPr>
+              <a:t>kierunkowo</a:t>
+            </a:r>
+          </a:p>
+        </p:txBody>
+      </p:sp>
     </p:spTree>
     <p:extLst>
       <p:ext uri="{BB962C8B-B14F-4D97-AF65-F5344CB8AC3E}">
@@ -18718,6 +19079,941 @@
           </a:p>
         </p:txBody>
       </p:sp>
+      <p:sp>
+        <p:nvSpPr>
+          <p:cNvPr id="101" name="Element 101"/>
+          <p:cNvSpPr/>
+          <p:nvPr/>
+        </p:nvSpPr>
+        <p:spPr>
+          <a:xfrm>
+            <a:off x="6126480" y="2011680"/>
+            <a:ext cx="1645920" cy="2103120"/>
+          </a:xfrm>
+          <a:prstGeom prst="rect">
+            <a:avLst/>
+          </a:prstGeom>
+          <a:noFill/>
+          <a:ln w="19050">
+            <a:solidFill>
+              <a:srgbClr val="E3B18D"/>
+            </a:solidFill>
+          </a:ln>
+        </p:spPr>
+        <p:txBody>
+          <a:bodyPr/>
+          <a:lstStyle/>
+          <a:p>
+            <a:endParaRPr lang="pl-PL"/>
+          </a:p>
+        </p:txBody>
+      </p:sp>
+      <p:sp>
+        <p:nvSpPr>
+          <p:cNvPr id="102" name="Element 102"/>
+          <p:cNvSpPr/>
+          <p:nvPr/>
+        </p:nvSpPr>
+        <p:spPr>
+          <a:xfrm>
+            <a:off x="6263640" y="2286000"/>
+            <a:ext cx="146304" cy="1645920"/>
+          </a:xfrm>
+          <a:prstGeom prst="rect">
+            <a:avLst/>
+          </a:prstGeom>
+          <a:solidFill>
+            <a:srgbClr val="E3B18D"/>
+          </a:solidFill>
+          <a:ln>
+            <a:noFill/>
+          </a:ln>
+        </p:spPr>
+        <p:txBody>
+          <a:bodyPr/>
+          <a:lstStyle/>
+          <a:p>
+            <a:endParaRPr lang="pl-PL"/>
+          </a:p>
+        </p:txBody>
+      </p:sp>
+      <p:sp>
+        <p:nvSpPr>
+          <p:cNvPr id="103" name="Element 103"/>
+          <p:cNvSpPr/>
+          <p:nvPr/>
+        </p:nvSpPr>
+        <p:spPr>
+          <a:xfrm>
+            <a:off x="6437376" y="2560320"/>
+            <a:ext cx="146304" cy="1371600"/>
+          </a:xfrm>
+          <a:prstGeom prst="rect">
+            <a:avLst/>
+          </a:prstGeom>
+          <a:solidFill>
+            <a:srgbClr val="E3B18D"/>
+          </a:solidFill>
+          <a:ln>
+            <a:noFill/>
+          </a:ln>
+        </p:spPr>
+        <p:txBody>
+          <a:bodyPr/>
+          <a:lstStyle/>
+          <a:p>
+            <a:endParaRPr lang="pl-PL"/>
+          </a:p>
+        </p:txBody>
+      </p:sp>
+      <p:sp>
+        <p:nvSpPr>
+          <p:cNvPr id="104" name="Element 104"/>
+          <p:cNvSpPr/>
+          <p:nvPr/>
+        </p:nvSpPr>
+        <p:spPr>
+          <a:xfrm>
+            <a:off x="6611112" y="3017520"/>
+            <a:ext cx="146304" cy="914400"/>
+          </a:xfrm>
+          <a:prstGeom prst="rect">
+            <a:avLst/>
+          </a:prstGeom>
+          <a:solidFill>
+            <a:srgbClr val="E3B18D"/>
+          </a:solidFill>
+          <a:ln>
+            <a:noFill/>
+          </a:ln>
+        </p:spPr>
+        <p:txBody>
+          <a:bodyPr/>
+          <a:lstStyle/>
+          <a:p>
+            <a:endParaRPr lang="pl-PL"/>
+          </a:p>
+        </p:txBody>
+      </p:sp>
+      <p:sp>
+        <p:nvSpPr>
+          <p:cNvPr id="105" name="Element 105"/>
+          <p:cNvSpPr/>
+          <p:nvPr/>
+        </p:nvSpPr>
+        <p:spPr>
+          <a:xfrm>
+            <a:off x="6784848" y="3383280"/>
+            <a:ext cx="146304" cy="548640"/>
+          </a:xfrm>
+          <a:prstGeom prst="rect">
+            <a:avLst/>
+          </a:prstGeom>
+          <a:solidFill>
+            <a:srgbClr val="E3B18D"/>
+          </a:solidFill>
+          <a:ln>
+            <a:noFill/>
+          </a:ln>
+        </p:spPr>
+        <p:txBody>
+          <a:bodyPr/>
+          <a:lstStyle/>
+          <a:p>
+            <a:endParaRPr lang="pl-PL"/>
+          </a:p>
+        </p:txBody>
+      </p:sp>
+      <p:sp>
+        <p:nvSpPr>
+          <p:cNvPr id="106" name="Element 106"/>
+          <p:cNvSpPr/>
+          <p:nvPr/>
+        </p:nvSpPr>
+        <p:spPr>
+          <a:xfrm>
+            <a:off x="6958584" y="3611880"/>
+            <a:ext cx="146304" cy="320040"/>
+          </a:xfrm>
+          <a:prstGeom prst="rect">
+            <a:avLst/>
+          </a:prstGeom>
+          <a:solidFill>
+            <a:srgbClr val="E3B18D"/>
+          </a:solidFill>
+          <a:ln>
+            <a:noFill/>
+          </a:ln>
+        </p:spPr>
+        <p:txBody>
+          <a:bodyPr/>
+          <a:lstStyle/>
+          <a:p>
+            <a:endParaRPr lang="pl-PL"/>
+          </a:p>
+        </p:txBody>
+      </p:sp>
+      <p:sp>
+        <p:nvSpPr>
+          <p:cNvPr id="107" name="Element 107"/>
+          <p:cNvSpPr/>
+          <p:nvPr/>
+        </p:nvSpPr>
+        <p:spPr>
+          <a:xfrm>
+            <a:off x="7132320" y="3749040"/>
+            <a:ext cx="146304" cy="182880"/>
+          </a:xfrm>
+          <a:prstGeom prst="rect">
+            <a:avLst/>
+          </a:prstGeom>
+          <a:solidFill>
+            <a:srgbClr val="E3B18D"/>
+          </a:solidFill>
+          <a:ln>
+            <a:noFill/>
+          </a:ln>
+        </p:spPr>
+        <p:txBody>
+          <a:bodyPr/>
+          <a:lstStyle/>
+          <a:p>
+            <a:endParaRPr lang="pl-PL"/>
+          </a:p>
+        </p:txBody>
+      </p:sp>
+      <p:sp>
+        <p:nvSpPr>
+          <p:cNvPr id="108" name="Element 108"/>
+          <p:cNvSpPr/>
+          <p:nvPr/>
+        </p:nvSpPr>
+        <p:spPr>
+          <a:xfrm>
+            <a:off x="7306056" y="3840480"/>
+            <a:ext cx="146304" cy="91440"/>
+          </a:xfrm>
+          <a:prstGeom prst="rect">
+            <a:avLst/>
+          </a:prstGeom>
+          <a:solidFill>
+            <a:srgbClr val="E3B18D"/>
+          </a:solidFill>
+          <a:ln>
+            <a:noFill/>
+          </a:ln>
+        </p:spPr>
+        <p:txBody>
+          <a:bodyPr/>
+          <a:lstStyle/>
+          <a:p>
+            <a:endParaRPr lang="pl-PL"/>
+          </a:p>
+        </p:txBody>
+      </p:sp>
+      <p:sp>
+        <p:nvSpPr>
+          <p:cNvPr id="109" name="Element 109"/>
+          <p:cNvSpPr/>
+          <p:nvPr/>
+        </p:nvSpPr>
+        <p:spPr>
+          <a:xfrm>
+            <a:off x="7479792" y="3886200"/>
+            <a:ext cx="146304" cy="45720"/>
+          </a:xfrm>
+          <a:prstGeom prst="rect">
+            <a:avLst/>
+          </a:prstGeom>
+          <a:solidFill>
+            <a:srgbClr val="E3B18D"/>
+          </a:solidFill>
+          <a:ln>
+            <a:noFill/>
+          </a:ln>
+        </p:spPr>
+        <p:txBody>
+          <a:bodyPr/>
+          <a:lstStyle/>
+          <a:p>
+            <a:endParaRPr lang="pl-PL"/>
+          </a:p>
+        </p:txBody>
+      </p:sp>
+      <p:sp>
+        <p:nvSpPr>
+          <p:cNvPr id="110" name="Element 110"/>
+          <p:cNvSpPr/>
+          <p:nvPr/>
+        </p:nvSpPr>
+        <p:spPr>
+          <a:xfrm>
+            <a:off x="6126480" y="4251960"/>
+            <a:ext cx="1645920" cy="365760"/>
+          </a:xfrm>
+          <a:prstGeom prst="rect">
+            <a:avLst/>
+          </a:prstGeom>
+          <a:noFill/>
+          <a:ln>
+            <a:noFill/>
+          </a:ln>
+        </p:spPr>
+        <p:txBody>
+          <a:bodyPr wrap="square" lIns="0" tIns="0" rIns="0" bIns="0" anchor="ctr">
+            <a:noAutofit/>
+          </a:bodyPr>
+          <a:lstStyle/>
+          <a:p>
+            <a:pPr algn="ctr"/>
+            <a:r>
+              <a:rPr lang="pl-PL" sz="1600" b="0" dirty="0">
+                <a:solidFill>
+                  <a:srgbClr val="8A8A8A"/>
+                </a:solidFill>
+                <a:latin typeface="+mn-lt"/>
+              </a:rPr>
+              <a:t>za ciemno</a:t>
+            </a:r>
+          </a:p>
+        </p:txBody>
+      </p:sp>
+      <p:sp>
+        <p:nvSpPr>
+          <p:cNvPr id="111" name="Element 111"/>
+          <p:cNvSpPr/>
+          <p:nvPr/>
+        </p:nvSpPr>
+        <p:spPr>
+          <a:xfrm>
+            <a:off x="7955280" y="2011680"/>
+            <a:ext cx="1645920" cy="2103120"/>
+          </a:xfrm>
+          <a:prstGeom prst="rect">
+            <a:avLst/>
+          </a:prstGeom>
+          <a:noFill/>
+          <a:ln w="19050">
+            <a:solidFill>
+              <a:srgbClr val="E3B18D"/>
+            </a:solidFill>
+          </a:ln>
+        </p:spPr>
+        <p:txBody>
+          <a:bodyPr/>
+          <a:lstStyle/>
+          <a:p>
+            <a:endParaRPr lang="pl-PL"/>
+          </a:p>
+        </p:txBody>
+      </p:sp>
+      <p:sp>
+        <p:nvSpPr>
+          <p:cNvPr id="112" name="Element 112"/>
+          <p:cNvSpPr/>
+          <p:nvPr/>
+        </p:nvSpPr>
+        <p:spPr>
+          <a:xfrm>
+            <a:off x="8092440" y="3749040"/>
+            <a:ext cx="146304" cy="182880"/>
+          </a:xfrm>
+          <a:prstGeom prst="rect">
+            <a:avLst/>
+          </a:prstGeom>
+          <a:solidFill>
+            <a:srgbClr val="E3B18D"/>
+          </a:solidFill>
+          <a:ln>
+            <a:noFill/>
+          </a:ln>
+        </p:spPr>
+        <p:txBody>
+          <a:bodyPr/>
+          <a:lstStyle/>
+          <a:p>
+            <a:endParaRPr lang="pl-PL"/>
+          </a:p>
+        </p:txBody>
+      </p:sp>
+      <p:sp>
+        <p:nvSpPr>
+          <p:cNvPr id="113" name="Element 113"/>
+          <p:cNvSpPr/>
+          <p:nvPr/>
+        </p:nvSpPr>
+        <p:spPr>
+          <a:xfrm>
+            <a:off x="8266176" y="3474720"/>
+            <a:ext cx="146304" cy="457200"/>
+          </a:xfrm>
+          <a:prstGeom prst="rect">
+            <a:avLst/>
+          </a:prstGeom>
+          <a:solidFill>
+            <a:srgbClr val="E3B18D"/>
+          </a:solidFill>
+          <a:ln>
+            <a:noFill/>
+          </a:ln>
+        </p:spPr>
+        <p:txBody>
+          <a:bodyPr/>
+          <a:lstStyle/>
+          <a:p>
+            <a:endParaRPr lang="pl-PL"/>
+          </a:p>
+        </p:txBody>
+      </p:sp>
+      <p:sp>
+        <p:nvSpPr>
+          <p:cNvPr id="114" name="Element 114"/>
+          <p:cNvSpPr/>
+          <p:nvPr/>
+        </p:nvSpPr>
+        <p:spPr>
+          <a:xfrm>
+            <a:off x="8439912" y="3108960"/>
+            <a:ext cx="146304" cy="822960"/>
+          </a:xfrm>
+          <a:prstGeom prst="rect">
+            <a:avLst/>
+          </a:prstGeom>
+          <a:solidFill>
+            <a:srgbClr val="E3B18D"/>
+          </a:solidFill>
+          <a:ln>
+            <a:noFill/>
+          </a:ln>
+        </p:spPr>
+        <p:txBody>
+          <a:bodyPr/>
+          <a:lstStyle/>
+          <a:p>
+            <a:endParaRPr lang="pl-PL"/>
+          </a:p>
+        </p:txBody>
+      </p:sp>
+      <p:sp>
+        <p:nvSpPr>
+          <p:cNvPr id="115" name="Element 115"/>
+          <p:cNvSpPr/>
+          <p:nvPr/>
+        </p:nvSpPr>
+        <p:spPr>
+          <a:xfrm>
+            <a:off x="8613648" y="2651760"/>
+            <a:ext cx="146304" cy="1280160"/>
+          </a:xfrm>
+          <a:prstGeom prst="rect">
+            <a:avLst/>
+          </a:prstGeom>
+          <a:solidFill>
+            <a:srgbClr val="E3B18D"/>
+          </a:solidFill>
+          <a:ln>
+            <a:noFill/>
+          </a:ln>
+        </p:spPr>
+        <p:txBody>
+          <a:bodyPr/>
+          <a:lstStyle/>
+          <a:p>
+            <a:endParaRPr lang="pl-PL"/>
+          </a:p>
+        </p:txBody>
+      </p:sp>
+      <p:sp>
+        <p:nvSpPr>
+          <p:cNvPr id="116" name="Element 116"/>
+          <p:cNvSpPr/>
+          <p:nvPr/>
+        </p:nvSpPr>
+        <p:spPr>
+          <a:xfrm>
+            <a:off x="8787384" y="2651760"/>
+            <a:ext cx="146304" cy="1280160"/>
+          </a:xfrm>
+          <a:prstGeom prst="rect">
+            <a:avLst/>
+          </a:prstGeom>
+          <a:solidFill>
+            <a:srgbClr val="E3B18D"/>
+          </a:solidFill>
+          <a:ln>
+            <a:noFill/>
+          </a:ln>
+        </p:spPr>
+        <p:txBody>
+          <a:bodyPr/>
+          <a:lstStyle/>
+          <a:p>
+            <a:endParaRPr lang="pl-PL"/>
+          </a:p>
+        </p:txBody>
+      </p:sp>
+      <p:sp>
+        <p:nvSpPr>
+          <p:cNvPr id="117" name="Element 117"/>
+          <p:cNvSpPr/>
+          <p:nvPr/>
+        </p:nvSpPr>
+        <p:spPr>
+          <a:xfrm>
+            <a:off x="8961120" y="3108960"/>
+            <a:ext cx="146304" cy="822960"/>
+          </a:xfrm>
+          <a:prstGeom prst="rect">
+            <a:avLst/>
+          </a:prstGeom>
+          <a:solidFill>
+            <a:srgbClr val="E3B18D"/>
+          </a:solidFill>
+          <a:ln>
+            <a:noFill/>
+          </a:ln>
+        </p:spPr>
+        <p:txBody>
+          <a:bodyPr/>
+          <a:lstStyle/>
+          <a:p>
+            <a:endParaRPr lang="pl-PL"/>
+          </a:p>
+        </p:txBody>
+      </p:sp>
+      <p:sp>
+        <p:nvSpPr>
+          <p:cNvPr id="118" name="Element 118"/>
+          <p:cNvSpPr/>
+          <p:nvPr/>
+        </p:nvSpPr>
+        <p:spPr>
+          <a:xfrm>
+            <a:off x="9134856" y="3474720"/>
+            <a:ext cx="146304" cy="457200"/>
+          </a:xfrm>
+          <a:prstGeom prst="rect">
+            <a:avLst/>
+          </a:prstGeom>
+          <a:solidFill>
+            <a:srgbClr val="E3B18D"/>
+          </a:solidFill>
+          <a:ln>
+            <a:noFill/>
+          </a:ln>
+        </p:spPr>
+        <p:txBody>
+          <a:bodyPr/>
+          <a:lstStyle/>
+          <a:p>
+            <a:endParaRPr lang="pl-PL"/>
+          </a:p>
+        </p:txBody>
+      </p:sp>
+      <p:sp>
+        <p:nvSpPr>
+          <p:cNvPr id="119" name="Element 119"/>
+          <p:cNvSpPr/>
+          <p:nvPr/>
+        </p:nvSpPr>
+        <p:spPr>
+          <a:xfrm>
+            <a:off x="9308592" y="3749040"/>
+            <a:ext cx="146304" cy="182880"/>
+          </a:xfrm>
+          <a:prstGeom prst="rect">
+            <a:avLst/>
+          </a:prstGeom>
+          <a:solidFill>
+            <a:srgbClr val="E3B18D"/>
+          </a:solidFill>
+          <a:ln>
+            <a:noFill/>
+          </a:ln>
+        </p:spPr>
+        <p:txBody>
+          <a:bodyPr/>
+          <a:lstStyle/>
+          <a:p>
+            <a:endParaRPr lang="pl-PL"/>
+          </a:p>
+        </p:txBody>
+      </p:sp>
+      <p:sp>
+        <p:nvSpPr>
+          <p:cNvPr id="120" name="Element 120"/>
+          <p:cNvSpPr/>
+          <p:nvPr/>
+        </p:nvSpPr>
+        <p:spPr>
+          <a:xfrm>
+            <a:off x="7955280" y="4251960"/>
+            <a:ext cx="1645920" cy="365760"/>
+          </a:xfrm>
+          <a:prstGeom prst="rect">
+            <a:avLst/>
+          </a:prstGeom>
+          <a:noFill/>
+          <a:ln>
+            <a:noFill/>
+          </a:ln>
+        </p:spPr>
+        <p:txBody>
+          <a:bodyPr wrap="square" lIns="0" tIns="0" rIns="0" bIns="0" anchor="ctr">
+            <a:noAutofit/>
+          </a:bodyPr>
+          <a:lstStyle/>
+          <a:p>
+            <a:pPr algn="ctr"/>
+            <a:r>
+              <a:rPr lang="pl-PL" sz="1600" b="1" dirty="0">
+                <a:solidFill>
+                  <a:srgbClr val="404040"/>
+                </a:solidFill>
+                <a:latin typeface="+mn-lt"/>
+              </a:rPr>
+              <a:t>OK</a:t>
+            </a:r>
+          </a:p>
+        </p:txBody>
+      </p:sp>
+      <p:sp>
+        <p:nvSpPr>
+          <p:cNvPr id="121" name="Element 121"/>
+          <p:cNvSpPr/>
+          <p:nvPr/>
+        </p:nvSpPr>
+        <p:spPr>
+          <a:xfrm>
+            <a:off x="9784080" y="2011680"/>
+            <a:ext cx="1645920" cy="2103120"/>
+          </a:xfrm>
+          <a:prstGeom prst="rect">
+            <a:avLst/>
+          </a:prstGeom>
+          <a:noFill/>
+          <a:ln w="19050">
+            <a:solidFill>
+              <a:srgbClr val="E3B18D"/>
+            </a:solidFill>
+          </a:ln>
+        </p:spPr>
+        <p:txBody>
+          <a:bodyPr/>
+          <a:lstStyle/>
+          <a:p>
+            <a:endParaRPr lang="pl-PL"/>
+          </a:p>
+        </p:txBody>
+      </p:sp>
+      <p:sp>
+        <p:nvSpPr>
+          <p:cNvPr id="122" name="Element 122"/>
+          <p:cNvSpPr/>
+          <p:nvPr/>
+        </p:nvSpPr>
+        <p:spPr>
+          <a:xfrm>
+            <a:off x="9921240" y="3886200"/>
+            <a:ext cx="146304" cy="45720"/>
+          </a:xfrm>
+          <a:prstGeom prst="rect">
+            <a:avLst/>
+          </a:prstGeom>
+          <a:solidFill>
+            <a:srgbClr val="E3B18D"/>
+          </a:solidFill>
+          <a:ln>
+            <a:noFill/>
+          </a:ln>
+        </p:spPr>
+        <p:txBody>
+          <a:bodyPr/>
+          <a:lstStyle/>
+          <a:p>
+            <a:endParaRPr lang="pl-PL"/>
+          </a:p>
+        </p:txBody>
+      </p:sp>
+      <p:sp>
+        <p:nvSpPr>
+          <p:cNvPr id="123" name="Element 123"/>
+          <p:cNvSpPr/>
+          <p:nvPr/>
+        </p:nvSpPr>
+        <p:spPr>
+          <a:xfrm>
+            <a:off x="10094976" y="3840480"/>
+            <a:ext cx="146304" cy="91440"/>
+          </a:xfrm>
+          <a:prstGeom prst="rect">
+            <a:avLst/>
+          </a:prstGeom>
+          <a:solidFill>
+            <a:srgbClr val="E3B18D"/>
+          </a:solidFill>
+          <a:ln>
+            <a:noFill/>
+          </a:ln>
+        </p:spPr>
+        <p:txBody>
+          <a:bodyPr/>
+          <a:lstStyle/>
+          <a:p>
+            <a:endParaRPr lang="pl-PL"/>
+          </a:p>
+        </p:txBody>
+      </p:sp>
+      <p:sp>
+        <p:nvSpPr>
+          <p:cNvPr id="124" name="Element 124"/>
+          <p:cNvSpPr/>
+          <p:nvPr/>
+        </p:nvSpPr>
+        <p:spPr>
+          <a:xfrm>
+            <a:off x="10268712" y="3749040"/>
+            <a:ext cx="146304" cy="182880"/>
+          </a:xfrm>
+          <a:prstGeom prst="rect">
+            <a:avLst/>
+          </a:prstGeom>
+          <a:solidFill>
+            <a:srgbClr val="E3B18D"/>
+          </a:solidFill>
+          <a:ln>
+            <a:noFill/>
+          </a:ln>
+        </p:spPr>
+        <p:txBody>
+          <a:bodyPr/>
+          <a:lstStyle/>
+          <a:p>
+            <a:endParaRPr lang="pl-PL"/>
+          </a:p>
+        </p:txBody>
+      </p:sp>
+      <p:sp>
+        <p:nvSpPr>
+          <p:cNvPr id="125" name="Element 125"/>
+          <p:cNvSpPr/>
+          <p:nvPr/>
+        </p:nvSpPr>
+        <p:spPr>
+          <a:xfrm>
+            <a:off x="10442448" y="3611880"/>
+            <a:ext cx="146304" cy="320040"/>
+          </a:xfrm>
+          <a:prstGeom prst="rect">
+            <a:avLst/>
+          </a:prstGeom>
+          <a:solidFill>
+            <a:srgbClr val="E3B18D"/>
+          </a:solidFill>
+          <a:ln>
+            <a:noFill/>
+          </a:ln>
+        </p:spPr>
+        <p:txBody>
+          <a:bodyPr/>
+          <a:lstStyle/>
+          <a:p>
+            <a:endParaRPr lang="pl-PL"/>
+          </a:p>
+        </p:txBody>
+      </p:sp>
+      <p:sp>
+        <p:nvSpPr>
+          <p:cNvPr id="126" name="Element 126"/>
+          <p:cNvSpPr/>
+          <p:nvPr/>
+        </p:nvSpPr>
+        <p:spPr>
+          <a:xfrm>
+            <a:off x="10616184" y="3383280"/>
+            <a:ext cx="146304" cy="548640"/>
+          </a:xfrm>
+          <a:prstGeom prst="rect">
+            <a:avLst/>
+          </a:prstGeom>
+          <a:solidFill>
+            <a:srgbClr val="E3B18D"/>
+          </a:solidFill>
+          <a:ln>
+            <a:noFill/>
+          </a:ln>
+        </p:spPr>
+        <p:txBody>
+          <a:bodyPr/>
+          <a:lstStyle/>
+          <a:p>
+            <a:endParaRPr lang="pl-PL"/>
+          </a:p>
+        </p:txBody>
+      </p:sp>
+      <p:sp>
+        <p:nvSpPr>
+          <p:cNvPr id="127" name="Element 127"/>
+          <p:cNvSpPr/>
+          <p:nvPr/>
+        </p:nvSpPr>
+        <p:spPr>
+          <a:xfrm>
+            <a:off x="10789920" y="3017520"/>
+            <a:ext cx="146304" cy="914400"/>
+          </a:xfrm>
+          <a:prstGeom prst="rect">
+            <a:avLst/>
+          </a:prstGeom>
+          <a:solidFill>
+            <a:srgbClr val="E3B18D"/>
+          </a:solidFill>
+          <a:ln>
+            <a:noFill/>
+          </a:ln>
+        </p:spPr>
+        <p:txBody>
+          <a:bodyPr/>
+          <a:lstStyle/>
+          <a:p>
+            <a:endParaRPr lang="pl-PL"/>
+          </a:p>
+        </p:txBody>
+      </p:sp>
+      <p:sp>
+        <p:nvSpPr>
+          <p:cNvPr id="128" name="Element 128"/>
+          <p:cNvSpPr/>
+          <p:nvPr/>
+        </p:nvSpPr>
+        <p:spPr>
+          <a:xfrm>
+            <a:off x="10963656" y="2560320"/>
+            <a:ext cx="146304" cy="1371600"/>
+          </a:xfrm>
+          <a:prstGeom prst="rect">
+            <a:avLst/>
+          </a:prstGeom>
+          <a:solidFill>
+            <a:srgbClr val="E3B18D"/>
+          </a:solidFill>
+          <a:ln>
+            <a:noFill/>
+          </a:ln>
+        </p:spPr>
+        <p:txBody>
+          <a:bodyPr/>
+          <a:lstStyle/>
+          <a:p>
+            <a:endParaRPr lang="pl-PL"/>
+          </a:p>
+        </p:txBody>
+      </p:sp>
+      <p:sp>
+        <p:nvSpPr>
+          <p:cNvPr id="129" name="Element 129"/>
+          <p:cNvSpPr/>
+          <p:nvPr/>
+        </p:nvSpPr>
+        <p:spPr>
+          <a:xfrm>
+            <a:off x="11137392" y="2286000"/>
+            <a:ext cx="146304" cy="1645920"/>
+          </a:xfrm>
+          <a:prstGeom prst="rect">
+            <a:avLst/>
+          </a:prstGeom>
+          <a:solidFill>
+            <a:srgbClr val="E3B18D"/>
+          </a:solidFill>
+          <a:ln>
+            <a:noFill/>
+          </a:ln>
+        </p:spPr>
+        <p:txBody>
+          <a:bodyPr/>
+          <a:lstStyle/>
+          <a:p>
+            <a:endParaRPr lang="pl-PL"/>
+          </a:p>
+        </p:txBody>
+      </p:sp>
+      <p:sp>
+        <p:nvSpPr>
+          <p:cNvPr id="130" name="Element 130"/>
+          <p:cNvSpPr/>
+          <p:nvPr/>
+        </p:nvSpPr>
+        <p:spPr>
+          <a:xfrm>
+            <a:off x="9784080" y="4251960"/>
+            <a:ext cx="1645920" cy="365760"/>
+          </a:xfrm>
+          <a:prstGeom prst="rect">
+            <a:avLst/>
+          </a:prstGeom>
+          <a:noFill/>
+          <a:ln>
+            <a:noFill/>
+          </a:ln>
+        </p:spPr>
+        <p:txBody>
+          <a:bodyPr wrap="square" lIns="0" tIns="0" rIns="0" bIns="0" anchor="ctr">
+            <a:noAutofit/>
+          </a:bodyPr>
+          <a:lstStyle/>
+          <a:p>
+            <a:pPr algn="ctr"/>
+            <a:r>
+              <a:rPr lang="pl-PL" sz="1600" b="0" dirty="0">
+                <a:solidFill>
+                  <a:srgbClr val="8A8A8A"/>
+                </a:solidFill>
+                <a:latin typeface="+mn-lt"/>
+              </a:rPr>
+              <a:t>za jasno</a:t>
+            </a:r>
+          </a:p>
+        </p:txBody>
+      </p:sp>
+      <p:sp>
+        <p:nvSpPr>
+          <p:cNvPr id="131" name="Element 131"/>
+          <p:cNvSpPr/>
+          <p:nvPr/>
+        </p:nvSpPr>
+        <p:spPr>
+          <a:xfrm>
+            <a:off x="6126480" y="4846320"/>
+            <a:ext cx="5303520" cy="365760"/>
+          </a:xfrm>
+          <a:prstGeom prst="rect">
+            <a:avLst/>
+          </a:prstGeom>
+          <a:noFill/>
+          <a:ln>
+            <a:noFill/>
+          </a:ln>
+        </p:spPr>
+        <p:txBody>
+          <a:bodyPr wrap="square" lIns="0" tIns="0" rIns="0" bIns="0" anchor="ctr">
+            <a:noAutofit/>
+          </a:bodyPr>
+          <a:lstStyle/>
+          <a:p>
+            <a:pPr algn="l"/>
+            <a:r>
+              <a:rPr lang="pl-PL" sz="1400" b="0" dirty="0">
+                <a:solidFill>
+                  <a:srgbClr val="8A8A8A"/>
+                </a:solidFill>
+                <a:latin typeface="+mn-lt"/>
+              </a:rPr>
+              <a:t>histogram: zły i dobry rozkład</a:t>
+            </a:r>
+          </a:p>
+        </p:txBody>
+      </p:sp>
     </p:spTree>
     <p:extLst>
       <p:ext uri="{BB962C8B-B14F-4D97-AF65-F5344CB8AC3E}">
@@ -18887,6 +20183,438 @@
           </a:p>
         </p:txBody>
       </p:sp>
+      <p:sp>
+        <p:nvSpPr>
+          <p:cNvPr id="101" name="Element 101"/>
+          <p:cNvSpPr/>
+          <p:nvPr/>
+        </p:nvSpPr>
+        <p:spPr>
+          <a:xfrm>
+            <a:off x="7406640" y="1645920"/>
+            <a:ext cx="914400" cy="914400"/>
+          </a:xfrm>
+          <a:prstGeom prst="ellipse">
+            <a:avLst/>
+          </a:prstGeom>
+          <a:noFill/>
+          <a:ln w="22225">
+            <a:solidFill>
+              <a:srgbClr val="404040"/>
+            </a:solidFill>
+          </a:ln>
+        </p:spPr>
+        <p:txBody>
+          <a:bodyPr/>
+          <a:lstStyle/>
+          <a:p>
+            <a:endParaRPr lang="pl-PL"/>
+          </a:p>
+        </p:txBody>
+      </p:sp>
+      <p:cxnSp>
+        <p:nvCxnSpPr>
+          <p:cNvPr id="102" name="Linia 102"/>
+          <p:cNvCxnSpPr/>
+          <p:nvPr/>
+        </p:nvCxnSpPr>
+        <p:spPr>
+          <a:xfrm>
+            <a:off x="7863840" y="2560320"/>
+            <a:ext cx="0" cy="1645920"/>
+          </a:xfrm>
+          <a:prstGeom prst="line">
+            <a:avLst/>
+          </a:prstGeom>
+          <a:ln w="22225">
+            <a:solidFill>
+              <a:srgbClr val="404040"/>
+            </a:solidFill>
+          </a:ln>
+        </p:spPr>
+      </p:cxnSp>
+      <p:cxnSp>
+        <p:nvCxnSpPr>
+          <p:cNvPr id="103" name="Linia 103"/>
+          <p:cNvCxnSpPr/>
+          <p:nvPr/>
+        </p:nvCxnSpPr>
+        <p:spPr>
+          <a:xfrm flipV="1">
+            <a:off x="7040880" y="2834640"/>
+            <a:ext cx="822960" cy="822960"/>
+          </a:xfrm>
+          <a:prstGeom prst="line">
+            <a:avLst/>
+          </a:prstGeom>
+          <a:ln w="22225">
+            <a:solidFill>
+              <a:srgbClr val="404040"/>
+            </a:solidFill>
+          </a:ln>
+        </p:spPr>
+      </p:cxnSp>
+      <p:cxnSp>
+        <p:nvCxnSpPr>
+          <p:cNvPr id="104" name="Linia 104"/>
+          <p:cNvCxnSpPr/>
+          <p:nvPr/>
+        </p:nvCxnSpPr>
+        <p:spPr>
+          <a:xfrm>
+            <a:off x="7863840" y="2834640"/>
+            <a:ext cx="822960" cy="731520"/>
+          </a:xfrm>
+          <a:prstGeom prst="line">
+            <a:avLst/>
+          </a:prstGeom>
+          <a:ln w="22225">
+            <a:solidFill>
+              <a:srgbClr val="404040"/>
+            </a:solidFill>
+          </a:ln>
+        </p:spPr>
+      </p:cxnSp>
+      <p:cxnSp>
+        <p:nvCxnSpPr>
+          <p:cNvPr id="105" name="Linia 105"/>
+          <p:cNvCxnSpPr/>
+          <p:nvPr/>
+        </p:nvCxnSpPr>
+        <p:spPr>
+          <a:xfrm flipV="1">
+            <a:off x="7406640" y="4206240"/>
+            <a:ext cx="457200" cy="1188720"/>
+          </a:xfrm>
+          <a:prstGeom prst="line">
+            <a:avLst/>
+          </a:prstGeom>
+          <a:ln w="22225">
+            <a:solidFill>
+              <a:srgbClr val="404040"/>
+            </a:solidFill>
+          </a:ln>
+        </p:spPr>
+      </p:cxnSp>
+      <p:cxnSp>
+        <p:nvCxnSpPr>
+          <p:cNvPr id="106" name="Linia 106"/>
+          <p:cNvCxnSpPr/>
+          <p:nvPr/>
+        </p:nvCxnSpPr>
+        <p:spPr>
+          <a:xfrm>
+            <a:off x="7863840" y="4206240"/>
+            <a:ext cx="457200" cy="1188720"/>
+          </a:xfrm>
+          <a:prstGeom prst="line">
+            <a:avLst/>
+          </a:prstGeom>
+          <a:ln w="22225">
+            <a:solidFill>
+              <a:srgbClr val="404040"/>
+            </a:solidFill>
+          </a:ln>
+        </p:spPr>
+      </p:cxnSp>
+      <p:sp>
+        <p:nvSpPr>
+          <p:cNvPr id="107" name="Element 107"/>
+          <p:cNvSpPr/>
+          <p:nvPr/>
+        </p:nvSpPr>
+        <p:spPr>
+          <a:xfrm>
+            <a:off x="6931152" y="3547872"/>
+            <a:ext cx="219456" cy="219456"/>
+          </a:xfrm>
+          <a:prstGeom prst="ellipse">
+            <a:avLst/>
+          </a:prstGeom>
+          <a:solidFill>
+            <a:srgbClr val="E3B18D"/>
+          </a:solidFill>
+          <a:ln>
+            <a:noFill/>
+          </a:ln>
+        </p:spPr>
+        <p:txBody>
+          <a:bodyPr/>
+          <a:lstStyle/>
+          <a:p>
+            <a:endParaRPr lang="pl-PL"/>
+          </a:p>
+        </p:txBody>
+      </p:sp>
+      <p:sp>
+        <p:nvSpPr>
+          <p:cNvPr id="108" name="Element 108"/>
+          <p:cNvSpPr/>
+          <p:nvPr/>
+        </p:nvSpPr>
+        <p:spPr>
+          <a:xfrm>
+            <a:off x="8577072" y="3456432"/>
+            <a:ext cx="219456" cy="219456"/>
+          </a:xfrm>
+          <a:prstGeom prst="ellipse">
+            <a:avLst/>
+          </a:prstGeom>
+          <a:solidFill>
+            <a:srgbClr val="E3B18D"/>
+          </a:solidFill>
+          <a:ln>
+            <a:noFill/>
+          </a:ln>
+        </p:spPr>
+        <p:txBody>
+          <a:bodyPr/>
+          <a:lstStyle/>
+          <a:p>
+            <a:endParaRPr lang="pl-PL"/>
+          </a:p>
+        </p:txBody>
+      </p:sp>
+      <p:cxnSp>
+        <p:nvCxnSpPr>
+          <p:cNvPr id="109" name="Strzałka 109"/>
+          <p:cNvCxnSpPr/>
+          <p:nvPr/>
+        </p:nvCxnSpPr>
+        <p:spPr>
+          <a:xfrm>
+            <a:off x="8366760" y="2103120"/>
+            <a:ext cx="1143000" cy="0"/>
+          </a:xfrm>
+          <a:prstGeom prst="line">
+            <a:avLst/>
+          </a:prstGeom>
+          <a:ln w="19050">
+            <a:solidFill>
+              <a:srgbClr val="E3B18D"/>
+            </a:solidFill>
+            <a:tailEnd type="triangle"/>
+          </a:ln>
+        </p:spPr>
+      </p:cxnSp>
+      <p:sp>
+        <p:nvSpPr>
+          <p:cNvPr id="110" name="Element 110"/>
+          <p:cNvSpPr/>
+          <p:nvPr/>
+        </p:nvSpPr>
+        <p:spPr>
+          <a:xfrm>
+            <a:off x="9601200" y="1920240"/>
+            <a:ext cx="1463040" cy="365760"/>
+          </a:xfrm>
+          <a:prstGeom prst="rect">
+            <a:avLst/>
+          </a:prstGeom>
+          <a:noFill/>
+          <a:ln>
+            <a:noFill/>
+          </a:ln>
+        </p:spPr>
+        <p:txBody>
+          <a:bodyPr wrap="square" lIns="0" tIns="0" rIns="0" bIns="0" anchor="ctr">
+            <a:noAutofit/>
+          </a:bodyPr>
+          <a:lstStyle/>
+          <a:p>
+            <a:pPr algn="l"/>
+            <a:r>
+              <a:rPr lang="pl-PL" sz="1600" b="0" dirty="0">
+                <a:solidFill>
+                  <a:srgbClr val="8A8A8A"/>
+                </a:solidFill>
+                <a:latin typeface="+mn-lt"/>
+              </a:rPr>
+              <a:t>wzrok</a:t>
+            </a:r>
+          </a:p>
+        </p:txBody>
+      </p:sp>
+      <p:cxnSp>
+        <p:nvCxnSpPr>
+          <p:cNvPr id="111" name="Linia 111"/>
+          <p:cNvCxnSpPr/>
+          <p:nvPr/>
+        </p:nvCxnSpPr>
+        <p:spPr>
+          <a:xfrm>
+            <a:off x="8046720" y="2468880"/>
+            <a:ext cx="1463040" cy="365760"/>
+          </a:xfrm>
+          <a:prstGeom prst="line">
+            <a:avLst/>
+          </a:prstGeom>
+          <a:ln w="12700">
+            <a:solidFill>
+              <a:srgbClr val="8A8A8A"/>
+            </a:solidFill>
+            <a:prstDash val="dash"/>
+          </a:ln>
+        </p:spPr>
+      </p:cxnSp>
+      <p:sp>
+        <p:nvSpPr>
+          <p:cNvPr id="112" name="Element 112"/>
+          <p:cNvSpPr/>
+          <p:nvPr/>
+        </p:nvSpPr>
+        <p:spPr>
+          <a:xfrm>
+            <a:off x="9601200" y="2651760"/>
+            <a:ext cx="1645920" cy="365760"/>
+          </a:xfrm>
+          <a:prstGeom prst="rect">
+            <a:avLst/>
+          </a:prstGeom>
+          <a:noFill/>
+          <a:ln>
+            <a:noFill/>
+          </a:ln>
+        </p:spPr>
+        <p:txBody>
+          <a:bodyPr wrap="square" lIns="0" tIns="0" rIns="0" bIns="0" anchor="ctr">
+            <a:noAutofit/>
+          </a:bodyPr>
+          <a:lstStyle/>
+          <a:p>
+            <a:pPr algn="l"/>
+            <a:r>
+              <a:rPr lang="pl-PL" sz="1600" b="0" dirty="0">
+                <a:solidFill>
+                  <a:srgbClr val="8A8A8A"/>
+                </a:solidFill>
+                <a:latin typeface="+mn-lt"/>
+              </a:rPr>
+              <a:t>ułożenie głowy</a:t>
+            </a:r>
+          </a:p>
+        </p:txBody>
+      </p:sp>
+      <p:cxnSp>
+        <p:nvCxnSpPr>
+          <p:cNvPr id="113" name="Linia 113"/>
+          <p:cNvCxnSpPr/>
+          <p:nvPr/>
+        </p:nvCxnSpPr>
+        <p:spPr>
+          <a:xfrm>
+            <a:off x="8732520" y="3566160"/>
+            <a:ext cx="777240" cy="182880"/>
+          </a:xfrm>
+          <a:prstGeom prst="line">
+            <a:avLst/>
+          </a:prstGeom>
+          <a:ln w="12700">
+            <a:solidFill>
+              <a:srgbClr val="8A8A8A"/>
+            </a:solidFill>
+            <a:prstDash val="dash"/>
+          </a:ln>
+        </p:spPr>
+      </p:cxnSp>
+      <p:sp>
+        <p:nvSpPr>
+          <p:cNvPr id="114" name="Element 114"/>
+          <p:cNvSpPr/>
+          <p:nvPr/>
+        </p:nvSpPr>
+        <p:spPr>
+          <a:xfrm>
+            <a:off x="9601200" y="3566160"/>
+            <a:ext cx="1463040" cy="365760"/>
+          </a:xfrm>
+          <a:prstGeom prst="rect">
+            <a:avLst/>
+          </a:prstGeom>
+          <a:noFill/>
+          <a:ln>
+            <a:noFill/>
+          </a:ln>
+        </p:spPr>
+        <p:txBody>
+          <a:bodyPr wrap="square" lIns="0" tIns="0" rIns="0" bIns="0" anchor="ctr">
+            <a:noAutofit/>
+          </a:bodyPr>
+          <a:lstStyle/>
+          <a:p>
+            <a:pPr algn="l"/>
+            <a:r>
+              <a:rPr lang="pl-PL" sz="1600" b="0" dirty="0">
+                <a:solidFill>
+                  <a:srgbClr val="8A8A8A"/>
+                </a:solidFill>
+                <a:latin typeface="+mn-lt"/>
+              </a:rPr>
+              <a:t>dłonie</a:t>
+            </a:r>
+          </a:p>
+        </p:txBody>
+      </p:sp>
+      <p:cxnSp>
+        <p:nvCxnSpPr>
+          <p:cNvPr id="115" name="Linia 115"/>
+          <p:cNvCxnSpPr/>
+          <p:nvPr/>
+        </p:nvCxnSpPr>
+        <p:spPr>
+          <a:xfrm>
+            <a:off x="8138160" y="4754880"/>
+            <a:ext cx="1371600" cy="182880"/>
+          </a:xfrm>
+          <a:prstGeom prst="line">
+            <a:avLst/>
+          </a:prstGeom>
+          <a:ln w="12700">
+            <a:solidFill>
+              <a:srgbClr val="8A8A8A"/>
+            </a:solidFill>
+            <a:prstDash val="dash"/>
+          </a:ln>
+        </p:spPr>
+      </p:cxnSp>
+      <p:sp>
+        <p:nvSpPr>
+          <p:cNvPr id="116" name="Element 116"/>
+          <p:cNvSpPr/>
+          <p:nvPr/>
+        </p:nvSpPr>
+        <p:spPr>
+          <a:xfrm>
+            <a:off x="9601200" y="4754880"/>
+            <a:ext cx="1737360" cy="365760"/>
+          </a:xfrm>
+          <a:prstGeom prst="rect">
+            <a:avLst/>
+          </a:prstGeom>
+          <a:noFill/>
+          <a:ln>
+            <a:noFill/>
+          </a:ln>
+        </p:spPr>
+        <p:txBody>
+          <a:bodyPr wrap="square" lIns="0" tIns="0" rIns="0" bIns="0" anchor="ctr">
+            <a:noAutofit/>
+          </a:bodyPr>
+          <a:lstStyle/>
+          <a:p>
+            <a:pPr algn="l"/>
+            <a:r>
+              <a:rPr lang="pl-PL" sz="1600" b="0" dirty="0">
+                <a:solidFill>
+                  <a:srgbClr val="8A8A8A"/>
+                </a:solidFill>
+                <a:latin typeface="+mn-lt"/>
+              </a:rPr>
+              <a:t>kierunek ciała</a:t>
+            </a:r>
+          </a:p>
+        </p:txBody>
+      </p:sp>
     </p:spTree>
     <p:extLst>
       <p:ext uri="{BB962C8B-B14F-4D97-AF65-F5344CB8AC3E}">
@@ -19999,6 +21727,370 @@
           </a:p>
         </p:txBody>
       </p:sp>
+      <p:sp>
+        <p:nvSpPr>
+          <p:cNvPr id="101" name="Element 101"/>
+          <p:cNvSpPr/>
+          <p:nvPr/>
+        </p:nvSpPr>
+        <p:spPr>
+          <a:xfrm>
+            <a:off x="6309360" y="4572000"/>
+            <a:ext cx="1371600" cy="274320"/>
+          </a:xfrm>
+          <a:prstGeom prst="ellipse">
+            <a:avLst/>
+          </a:prstGeom>
+          <a:solidFill>
+            <a:srgbClr val="404040">
+              <a:alpha val="25000"/>
+            </a:srgbClr>
+          </a:solidFill>
+          <a:ln>
+            <a:noFill/>
+          </a:ln>
+        </p:spPr>
+        <p:txBody>
+          <a:bodyPr/>
+          <a:lstStyle/>
+          <a:p>
+            <a:endParaRPr lang="pl-PL"/>
+          </a:p>
+        </p:txBody>
+      </p:sp>
+      <p:sp>
+        <p:nvSpPr>
+          <p:cNvPr id="102" name="Element 102"/>
+          <p:cNvSpPr/>
+          <p:nvPr/>
+        </p:nvSpPr>
+        <p:spPr>
+          <a:xfrm>
+            <a:off x="6400800" y="2560320"/>
+            <a:ext cx="914400" cy="2103120"/>
+          </a:xfrm>
+          <a:prstGeom prst="trapezoid">
+            <a:avLst/>
+          </a:prstGeom>
+          <a:noFill/>
+          <a:ln w="22225">
+            <a:solidFill>
+              <a:srgbClr val="404040"/>
+            </a:solidFill>
+          </a:ln>
+        </p:spPr>
+        <p:txBody>
+          <a:bodyPr/>
+          <a:lstStyle/>
+          <a:p>
+            <a:endParaRPr lang="pl-PL"/>
+          </a:p>
+        </p:txBody>
+      </p:sp>
+      <p:sp>
+        <p:nvSpPr>
+          <p:cNvPr id="103" name="Element 103"/>
+          <p:cNvSpPr/>
+          <p:nvPr/>
+        </p:nvSpPr>
+        <p:spPr>
+          <a:xfrm>
+            <a:off x="6583680" y="2743200"/>
+            <a:ext cx="73152" cy="1645920"/>
+          </a:xfrm>
+          <a:prstGeom prst="rect">
+            <a:avLst/>
+          </a:prstGeom>
+          <a:solidFill>
+            <a:srgbClr val="E3B18D">
+              <a:alpha val="70000"/>
+            </a:srgbClr>
+          </a:solidFill>
+          <a:ln>
+            <a:noFill/>
+          </a:ln>
+        </p:spPr>
+        <p:txBody>
+          <a:bodyPr/>
+          <a:lstStyle/>
+          <a:p>
+            <a:endParaRPr lang="pl-PL"/>
+          </a:p>
+        </p:txBody>
+      </p:sp>
+      <p:sp>
+        <p:nvSpPr>
+          <p:cNvPr id="104" name="Element 104"/>
+          <p:cNvSpPr/>
+          <p:nvPr/>
+        </p:nvSpPr>
+        <p:spPr>
+          <a:xfrm>
+            <a:off x="6126480" y="5029200"/>
+            <a:ext cx="1463040" cy="365760"/>
+          </a:xfrm>
+          <a:prstGeom prst="rect">
+            <a:avLst/>
+          </a:prstGeom>
+          <a:noFill/>
+          <a:ln>
+            <a:noFill/>
+          </a:ln>
+        </p:spPr>
+        <p:txBody>
+          <a:bodyPr wrap="square" lIns="0" tIns="0" rIns="0" bIns="0" anchor="ctr">
+            <a:noAutofit/>
+          </a:bodyPr>
+          <a:lstStyle/>
+          <a:p>
+            <a:pPr algn="ctr"/>
+            <a:r>
+              <a:rPr lang="pl-PL" sz="1600" b="0" dirty="0">
+                <a:solidFill>
+                  <a:srgbClr val="8A8A8A"/>
+                </a:solidFill>
+                <a:latin typeface="+mn-lt"/>
+              </a:rPr>
+              <a:t>szkło</a:t>
+            </a:r>
+          </a:p>
+        </p:txBody>
+      </p:sp>
+      <p:sp>
+        <p:nvSpPr>
+          <p:cNvPr id="105" name="Element 105"/>
+          <p:cNvSpPr/>
+          <p:nvPr/>
+        </p:nvSpPr>
+        <p:spPr>
+          <a:xfrm>
+            <a:off x="8229600" y="4572000"/>
+            <a:ext cx="1371600" cy="274320"/>
+          </a:xfrm>
+          <a:prstGeom prst="ellipse">
+            <a:avLst/>
+          </a:prstGeom>
+          <a:solidFill>
+            <a:srgbClr val="404040">
+              <a:alpha val="25000"/>
+            </a:srgbClr>
+          </a:solidFill>
+          <a:ln>
+            <a:noFill/>
+          </a:ln>
+        </p:spPr>
+        <p:txBody>
+          <a:bodyPr/>
+          <a:lstStyle/>
+          <a:p>
+            <a:endParaRPr lang="pl-PL"/>
+          </a:p>
+        </p:txBody>
+      </p:sp>
+      <p:sp>
+        <p:nvSpPr>
+          <p:cNvPr id="106" name="Gradient 106"/>
+          <p:cNvSpPr/>
+          <p:nvPr/>
+        </p:nvSpPr>
+        <p:spPr>
+          <a:xfrm>
+            <a:off x="8366760" y="2560320"/>
+            <a:ext cx="822960" cy="2103120"/>
+          </a:xfrm>
+          <a:prstGeom prst="rect">
+            <a:avLst/>
+          </a:prstGeom>
+          <a:gradFill>
+            <a:gsLst>
+              <a:gs pos="0">
+                <a:srgbClr val="D5D8DC"/>
+              </a:gs>
+              <a:gs pos="100000">
+                <a:srgbClr val="6E7378"/>
+              </a:gs>
+            </a:gsLst>
+            <a:lin ang="0" scaled="0"/>
+          </a:gradFill>
+          <a:ln>
+            <a:noFill/>
+          </a:ln>
+        </p:spPr>
+        <p:txBody>
+          <a:bodyPr/>
+          <a:lstStyle/>
+          <a:p>
+            <a:endParaRPr lang="pl-PL"/>
+          </a:p>
+        </p:txBody>
+      </p:sp>
+      <p:sp>
+        <p:nvSpPr>
+          <p:cNvPr id="107" name="Element 107"/>
+          <p:cNvSpPr/>
+          <p:nvPr/>
+        </p:nvSpPr>
+        <p:spPr>
+          <a:xfrm>
+            <a:off x="8595360" y="2560320"/>
+            <a:ext cx="73152" cy="2103120"/>
+          </a:xfrm>
+          <a:prstGeom prst="rect">
+            <a:avLst/>
+          </a:prstGeom>
+          <a:solidFill>
+            <a:srgbClr val="FFFFFF">
+              <a:alpha val="80000"/>
+            </a:srgbClr>
+          </a:solidFill>
+          <a:ln>
+            <a:noFill/>
+          </a:ln>
+        </p:spPr>
+        <p:txBody>
+          <a:bodyPr/>
+          <a:lstStyle/>
+          <a:p>
+            <a:endParaRPr lang="pl-PL"/>
+          </a:p>
+        </p:txBody>
+      </p:sp>
+      <p:sp>
+        <p:nvSpPr>
+          <p:cNvPr id="108" name="Element 108"/>
+          <p:cNvSpPr/>
+          <p:nvPr/>
+        </p:nvSpPr>
+        <p:spPr>
+          <a:xfrm>
+            <a:off x="8046720" y="5029200"/>
+            <a:ext cx="1463040" cy="365760"/>
+          </a:xfrm>
+          <a:prstGeom prst="rect">
+            <a:avLst/>
+          </a:prstGeom>
+          <a:noFill/>
+          <a:ln>
+            <a:noFill/>
+          </a:ln>
+        </p:spPr>
+        <p:txBody>
+          <a:bodyPr wrap="square" lIns="0" tIns="0" rIns="0" bIns="0" anchor="ctr">
+            <a:noAutofit/>
+          </a:bodyPr>
+          <a:lstStyle/>
+          <a:p>
+            <a:pPr algn="ctr"/>
+            <a:r>
+              <a:rPr lang="pl-PL" sz="1600" b="0" dirty="0">
+                <a:solidFill>
+                  <a:srgbClr val="8A8A8A"/>
+                </a:solidFill>
+                <a:latin typeface="+mn-lt"/>
+              </a:rPr>
+              <a:t>metal</a:t>
+            </a:r>
+          </a:p>
+        </p:txBody>
+      </p:sp>
+      <p:sp>
+        <p:nvSpPr>
+          <p:cNvPr id="109" name="Element 109"/>
+          <p:cNvSpPr/>
+          <p:nvPr/>
+        </p:nvSpPr>
+        <p:spPr>
+          <a:xfrm>
+            <a:off x="10149840" y="4572000"/>
+            <a:ext cx="1371600" cy="274320"/>
+          </a:xfrm>
+          <a:prstGeom prst="ellipse">
+            <a:avLst/>
+          </a:prstGeom>
+          <a:solidFill>
+            <a:srgbClr val="404040">
+              <a:alpha val="25000"/>
+            </a:srgbClr>
+          </a:solidFill>
+          <a:ln>
+            <a:noFill/>
+          </a:ln>
+        </p:spPr>
+        <p:txBody>
+          <a:bodyPr/>
+          <a:lstStyle/>
+          <a:p>
+            <a:endParaRPr lang="pl-PL"/>
+          </a:p>
+        </p:txBody>
+      </p:sp>
+      <p:sp>
+        <p:nvSpPr>
+          <p:cNvPr id="110" name="Element 110"/>
+          <p:cNvSpPr/>
+          <p:nvPr/>
+        </p:nvSpPr>
+        <p:spPr>
+          <a:xfrm>
+            <a:off x="10241280" y="2560320"/>
+            <a:ext cx="914400" cy="2103120"/>
+          </a:xfrm>
+          <a:prstGeom prst="roundRect">
+            <a:avLst/>
+          </a:prstGeom>
+          <a:solidFill>
+            <a:srgbClr val="C9CDD2"/>
+          </a:solidFill>
+          <a:ln>
+            <a:noFill/>
+          </a:ln>
+        </p:spPr>
+        <p:txBody>
+          <a:bodyPr/>
+          <a:lstStyle/>
+          <a:p>
+            <a:endParaRPr lang="pl-PL"/>
+          </a:p>
+        </p:txBody>
+      </p:sp>
+      <p:sp>
+        <p:nvSpPr>
+          <p:cNvPr id="111" name="Element 111"/>
+          <p:cNvSpPr/>
+          <p:nvPr/>
+        </p:nvSpPr>
+        <p:spPr>
+          <a:xfrm>
+            <a:off x="9966960" y="5029200"/>
+            <a:ext cx="1463040" cy="365760"/>
+          </a:xfrm>
+          <a:prstGeom prst="rect">
+            <a:avLst/>
+          </a:prstGeom>
+          <a:noFill/>
+          <a:ln>
+            <a:noFill/>
+          </a:ln>
+        </p:spPr>
+        <p:txBody>
+          <a:bodyPr wrap="square" lIns="0" tIns="0" rIns="0" bIns="0" anchor="ctr">
+            <a:noAutofit/>
+          </a:bodyPr>
+          <a:lstStyle/>
+          <a:p>
+            <a:pPr algn="ctr"/>
+            <a:r>
+              <a:rPr lang="pl-PL" sz="1600" b="0" dirty="0">
+                <a:solidFill>
+                  <a:srgbClr val="8A8A8A"/>
+                </a:solidFill>
+                <a:latin typeface="+mn-lt"/>
+              </a:rPr>
+              <a:t>plastik</a:t>
+            </a:r>
+          </a:p>
+        </p:txBody>
+      </p:sp>
     </p:spTree>
     <p:extLst>
       <p:ext uri="{BB962C8B-B14F-4D97-AF65-F5344CB8AC3E}">
@@ -20726,6 +22818,286 @@
           </a:p>
         </p:txBody>
       </p:sp>
+      <p:sp>
+        <p:nvSpPr>
+          <p:cNvPr id="101" name="Element 101"/>
+          <p:cNvSpPr/>
+          <p:nvPr/>
+        </p:nvSpPr>
+        <p:spPr>
+          <a:xfrm>
+            <a:off x="6309360" y="1737360"/>
+            <a:ext cx="5120640" cy="3291840"/>
+          </a:xfrm>
+          <a:prstGeom prst="rect">
+            <a:avLst/>
+          </a:prstGeom>
+          <a:noFill/>
+          <a:ln w="22225">
+            <a:solidFill>
+              <a:srgbClr val="404040"/>
+            </a:solidFill>
+          </a:ln>
+        </p:spPr>
+        <p:txBody>
+          <a:bodyPr/>
+          <a:lstStyle/>
+          <a:p>
+            <a:endParaRPr lang="pl-PL"/>
+          </a:p>
+        </p:txBody>
+      </p:sp>
+      <p:cxnSp>
+        <p:nvCxnSpPr>
+          <p:cNvPr id="102" name="Linia 102"/>
+          <p:cNvCxnSpPr/>
+          <p:nvPr/>
+        </p:nvCxnSpPr>
+        <p:spPr>
+          <a:xfrm>
+            <a:off x="8016240" y="1737360"/>
+            <a:ext cx="0" cy="3291840"/>
+          </a:xfrm>
+          <a:prstGeom prst="line">
+            <a:avLst/>
+          </a:prstGeom>
+          <a:ln w="12700">
+            <a:solidFill>
+              <a:srgbClr val="E3B18D"/>
+            </a:solidFill>
+            <a:prstDash val="dash"/>
+          </a:ln>
+        </p:spPr>
+      </p:cxnSp>
+      <p:cxnSp>
+        <p:nvCxnSpPr>
+          <p:cNvPr id="103" name="Linia 103"/>
+          <p:cNvCxnSpPr/>
+          <p:nvPr/>
+        </p:nvCxnSpPr>
+        <p:spPr>
+          <a:xfrm>
+            <a:off x="6309360" y="2834640"/>
+            <a:ext cx="5120640" cy="0"/>
+          </a:xfrm>
+          <a:prstGeom prst="line">
+            <a:avLst/>
+          </a:prstGeom>
+          <a:ln w="12700">
+            <a:solidFill>
+              <a:srgbClr val="E3B18D"/>
+            </a:solidFill>
+            <a:prstDash val="dash"/>
+          </a:ln>
+        </p:spPr>
+      </p:cxnSp>
+      <p:cxnSp>
+        <p:nvCxnSpPr>
+          <p:cNvPr id="104" name="Linia 104"/>
+          <p:cNvCxnSpPr/>
+          <p:nvPr/>
+        </p:nvCxnSpPr>
+        <p:spPr>
+          <a:xfrm>
+            <a:off x="9723120" y="1737360"/>
+            <a:ext cx="0" cy="3291840"/>
+          </a:xfrm>
+          <a:prstGeom prst="line">
+            <a:avLst/>
+          </a:prstGeom>
+          <a:ln w="12700">
+            <a:solidFill>
+              <a:srgbClr val="E3B18D"/>
+            </a:solidFill>
+            <a:prstDash val="dash"/>
+          </a:ln>
+        </p:spPr>
+      </p:cxnSp>
+      <p:cxnSp>
+        <p:nvCxnSpPr>
+          <p:cNvPr id="105" name="Linia 105"/>
+          <p:cNvCxnSpPr/>
+          <p:nvPr/>
+        </p:nvCxnSpPr>
+        <p:spPr>
+          <a:xfrm>
+            <a:off x="6309360" y="3931920"/>
+            <a:ext cx="5120640" cy="0"/>
+          </a:xfrm>
+          <a:prstGeom prst="line">
+            <a:avLst/>
+          </a:prstGeom>
+          <a:ln w="12700">
+            <a:solidFill>
+              <a:srgbClr val="E3B18D"/>
+            </a:solidFill>
+            <a:prstDash val="dash"/>
+          </a:ln>
+        </p:spPr>
+      </p:cxnSp>
+      <p:sp>
+        <p:nvSpPr>
+          <p:cNvPr id="106" name="Element 106"/>
+          <p:cNvSpPr/>
+          <p:nvPr/>
+        </p:nvSpPr>
+        <p:spPr>
+          <a:xfrm>
+            <a:off x="9174480" y="3383280"/>
+            <a:ext cx="1097280" cy="1097280"/>
+          </a:xfrm>
+          <a:prstGeom prst="ellipse">
+            <a:avLst/>
+          </a:prstGeom>
+          <a:solidFill>
+            <a:srgbClr val="E3B18D"/>
+          </a:solidFill>
+          <a:ln>
+            <a:noFill/>
+          </a:ln>
+        </p:spPr>
+        <p:txBody>
+          <a:bodyPr/>
+          <a:lstStyle/>
+          <a:p>
+            <a:endParaRPr lang="pl-PL"/>
+          </a:p>
+        </p:txBody>
+      </p:sp>
+      <p:sp>
+        <p:nvSpPr>
+          <p:cNvPr id="107" name="Element 107"/>
+          <p:cNvSpPr/>
+          <p:nvPr/>
+        </p:nvSpPr>
+        <p:spPr>
+          <a:xfrm>
+            <a:off x="9174480" y="4572000"/>
+            <a:ext cx="1097280" cy="365760"/>
+          </a:xfrm>
+          <a:prstGeom prst="rect">
+            <a:avLst/>
+          </a:prstGeom>
+          <a:noFill/>
+          <a:ln>
+            <a:noFill/>
+          </a:ln>
+        </p:spPr>
+        <p:txBody>
+          <a:bodyPr wrap="square" lIns="0" tIns="0" rIns="0" bIns="0" anchor="ctr">
+            <a:noAutofit/>
+          </a:bodyPr>
+          <a:lstStyle/>
+          <a:p>
+            <a:pPr algn="ctr"/>
+            <a:r>
+              <a:rPr lang="pl-PL" sz="1600" b="1" dirty="0">
+                <a:solidFill>
+                  <a:srgbClr val="404040"/>
+                </a:solidFill>
+                <a:latin typeface="+mn-lt"/>
+              </a:rPr>
+              <a:t>hero</a:t>
+            </a:r>
+          </a:p>
+        </p:txBody>
+      </p:sp>
+      <p:sp>
+        <p:nvSpPr>
+          <p:cNvPr id="108" name="Element 108"/>
+          <p:cNvSpPr/>
+          <p:nvPr/>
+        </p:nvSpPr>
+        <p:spPr>
+          <a:xfrm>
+            <a:off x="7723632" y="2633472"/>
+            <a:ext cx="402336" cy="402336"/>
+          </a:xfrm>
+          <a:prstGeom prst="ellipse">
+            <a:avLst/>
+          </a:prstGeom>
+          <a:noFill/>
+          <a:ln w="19050">
+            <a:solidFill>
+              <a:srgbClr val="404040"/>
+            </a:solidFill>
+          </a:ln>
+        </p:spPr>
+        <p:txBody>
+          <a:bodyPr/>
+          <a:lstStyle/>
+          <a:p>
+            <a:endParaRPr lang="pl-PL"/>
+          </a:p>
+        </p:txBody>
+      </p:sp>
+      <p:sp>
+        <p:nvSpPr>
+          <p:cNvPr id="109" name="Element 109"/>
+          <p:cNvSpPr/>
+          <p:nvPr/>
+        </p:nvSpPr>
+        <p:spPr>
+          <a:xfrm>
+            <a:off x="7077456" y="4242816"/>
+            <a:ext cx="292608" cy="292608"/>
+          </a:xfrm>
+          <a:prstGeom prst="ellipse">
+            <a:avLst/>
+          </a:prstGeom>
+          <a:noFill/>
+          <a:ln w="19050">
+            <a:solidFill>
+              <a:srgbClr val="404040"/>
+            </a:solidFill>
+          </a:ln>
+        </p:spPr>
+        <p:txBody>
+          <a:bodyPr/>
+          <a:lstStyle/>
+          <a:p>
+            <a:endParaRPr lang="pl-PL"/>
+          </a:p>
+        </p:txBody>
+      </p:sp>
+      <p:sp>
+        <p:nvSpPr>
+          <p:cNvPr id="110" name="Element 110"/>
+          <p:cNvSpPr/>
+          <p:nvPr/>
+        </p:nvSpPr>
+        <p:spPr>
+          <a:xfrm>
+            <a:off x="6309360" y="5166360"/>
+            <a:ext cx="5120640" cy="365760"/>
+          </a:xfrm>
+          <a:prstGeom prst="rect">
+            <a:avLst/>
+          </a:prstGeom>
+          <a:noFill/>
+          <a:ln>
+            <a:noFill/>
+          </a:ln>
+        </p:spPr>
+        <p:txBody>
+          <a:bodyPr wrap="square" lIns="0" tIns="0" rIns="0" bIns="0" anchor="ctr">
+            <a:noAutofit/>
+          </a:bodyPr>
+          <a:lstStyle/>
+          <a:p>
+            <a:pPr algn="l"/>
+            <a:r>
+              <a:rPr lang="pl-PL" sz="1600" b="0" dirty="0">
+                <a:solidFill>
+                  <a:srgbClr val="8A8A8A"/>
+                </a:solidFill>
+                <a:latin typeface="+mn-lt"/>
+              </a:rPr>
+              <a:t>hierarchia w kadrze</a:t>
+            </a:r>
+          </a:p>
+        </p:txBody>
+      </p:sp>
     </p:spTree>
     <p:extLst>
       <p:ext uri="{BB962C8B-B14F-4D97-AF65-F5344CB8AC3E}">
@@ -20877,6 +23249,325 @@
           </a:p>
         </p:txBody>
       </p:sp>
+      <p:sp>
+        <p:nvSpPr>
+          <p:cNvPr id="101" name="Element 101"/>
+          <p:cNvSpPr/>
+          <p:nvPr/>
+        </p:nvSpPr>
+        <p:spPr>
+          <a:xfrm rot="8100000">
+            <a:off x="6400800" y="1280160"/>
+            <a:ext cx="2743200" cy="2743200"/>
+          </a:xfrm>
+          <a:prstGeom prst="triangle">
+            <a:avLst/>
+          </a:prstGeom>
+          <a:solidFill>
+            <a:srgbClr val="E3B18D">
+              <a:alpha val="18000"/>
+            </a:srgbClr>
+          </a:solidFill>
+          <a:ln>
+            <a:noFill/>
+          </a:ln>
+        </p:spPr>
+        <p:txBody>
+          <a:bodyPr/>
+          <a:lstStyle/>
+          <a:p>
+            <a:endParaRPr lang="pl-PL"/>
+          </a:p>
+        </p:txBody>
+      </p:sp>
+      <p:sp>
+        <p:nvSpPr>
+          <p:cNvPr id="102" name="Element 102"/>
+          <p:cNvSpPr/>
+          <p:nvPr/>
+        </p:nvSpPr>
+        <p:spPr>
+          <a:xfrm>
+            <a:off x="6327648" y="1115568"/>
+            <a:ext cx="512064" cy="512064"/>
+          </a:xfrm>
+          <a:prstGeom prst="ellipse">
+            <a:avLst/>
+          </a:prstGeom>
+          <a:solidFill>
+            <a:srgbClr val="E3B18D"/>
+          </a:solidFill>
+          <a:ln>
+            <a:noFill/>
+          </a:ln>
+        </p:spPr>
+        <p:txBody>
+          <a:bodyPr/>
+          <a:lstStyle/>
+          <a:p>
+            <a:endParaRPr lang="pl-PL"/>
+          </a:p>
+        </p:txBody>
+      </p:sp>
+      <p:sp>
+        <p:nvSpPr>
+          <p:cNvPr id="103" name="Element 103"/>
+          <p:cNvSpPr/>
+          <p:nvPr/>
+        </p:nvSpPr>
+        <p:spPr>
+          <a:xfrm>
+            <a:off x="6126480" y="1737360"/>
+            <a:ext cx="914400" cy="365760"/>
+          </a:xfrm>
+          <a:prstGeom prst="rect">
+            <a:avLst/>
+          </a:prstGeom>
+          <a:noFill/>
+          <a:ln>
+            <a:noFill/>
+          </a:ln>
+        </p:spPr>
+        <p:txBody>
+          <a:bodyPr wrap="square" lIns="0" tIns="0" rIns="0" bIns="0" anchor="ctr">
+            <a:noAutofit/>
+          </a:bodyPr>
+          <a:lstStyle/>
+          <a:p>
+            <a:pPr algn="ctr"/>
+            <a:r>
+              <a:rPr lang="pl-PL" sz="1400" b="0" dirty="0">
+                <a:solidFill>
+                  <a:srgbClr val="8A8A8A"/>
+                </a:solidFill>
+                <a:latin typeface="+mn-lt"/>
+              </a:rPr>
+              <a:t>światło</a:t>
+            </a:r>
+          </a:p>
+        </p:txBody>
+      </p:sp>
+      <p:sp>
+        <p:nvSpPr>
+          <p:cNvPr id="104" name="Element 104"/>
+          <p:cNvSpPr/>
+          <p:nvPr/>
+        </p:nvSpPr>
+        <p:spPr>
+          <a:xfrm>
+            <a:off x="8138160" y="2651760"/>
+            <a:ext cx="914400" cy="914400"/>
+          </a:xfrm>
+          <a:prstGeom prst="ellipse">
+            <a:avLst/>
+          </a:prstGeom>
+          <a:noFill/>
+          <a:ln w="22225">
+            <a:solidFill>
+              <a:srgbClr val="404040"/>
+            </a:solidFill>
+          </a:ln>
+        </p:spPr>
+        <p:txBody>
+          <a:bodyPr/>
+          <a:lstStyle/>
+          <a:p>
+            <a:endParaRPr lang="pl-PL"/>
+          </a:p>
+        </p:txBody>
+      </p:sp>
+      <p:sp>
+        <p:nvSpPr>
+          <p:cNvPr id="105" name="Element 105"/>
+          <p:cNvSpPr/>
+          <p:nvPr/>
+        </p:nvSpPr>
+        <p:spPr>
+          <a:xfrm>
+            <a:off x="7955280" y="3657600"/>
+            <a:ext cx="1280160" cy="1280160"/>
+          </a:xfrm>
+          <a:prstGeom prst="round2SameRect">
+            <a:avLst/>
+          </a:prstGeom>
+          <a:noFill/>
+          <a:ln w="22225">
+            <a:solidFill>
+              <a:srgbClr val="404040"/>
+            </a:solidFill>
+          </a:ln>
+        </p:spPr>
+        <p:txBody>
+          <a:bodyPr/>
+          <a:lstStyle/>
+          <a:p>
+            <a:endParaRPr lang="pl-PL"/>
+          </a:p>
+        </p:txBody>
+      </p:sp>
+      <p:sp>
+        <p:nvSpPr>
+          <p:cNvPr id="106" name="Element 106"/>
+          <p:cNvSpPr/>
+          <p:nvPr/>
+        </p:nvSpPr>
+        <p:spPr>
+          <a:xfrm>
+            <a:off x="7955280" y="5120640"/>
+            <a:ext cx="1280160" cy="365760"/>
+          </a:xfrm>
+          <a:prstGeom prst="rect">
+            <a:avLst/>
+          </a:prstGeom>
+          <a:noFill/>
+          <a:ln>
+            <a:noFill/>
+          </a:ln>
+        </p:spPr>
+        <p:txBody>
+          <a:bodyPr wrap="square" lIns="0" tIns="0" rIns="0" bIns="0" anchor="ctr">
+            <a:noAutofit/>
+          </a:bodyPr>
+          <a:lstStyle/>
+          <a:p>
+            <a:pPr algn="ctr"/>
+            <a:r>
+              <a:rPr lang="pl-PL" sz="1600" b="0" dirty="0">
+                <a:solidFill>
+                  <a:srgbClr val="8A8A8A"/>
+                </a:solidFill>
+                <a:latin typeface="+mn-lt"/>
+              </a:rPr>
+              <a:t>model</a:t>
+            </a:r>
+          </a:p>
+        </p:txBody>
+      </p:sp>
+      <p:sp>
+        <p:nvSpPr>
+          <p:cNvPr id="107" name="Element 107"/>
+          <p:cNvSpPr/>
+          <p:nvPr/>
+        </p:nvSpPr>
+        <p:spPr>
+          <a:xfrm>
+            <a:off x="10058400" y="3566160"/>
+            <a:ext cx="914400" cy="1371600"/>
+          </a:xfrm>
+          <a:prstGeom prst="roundRect">
+            <a:avLst/>
+          </a:prstGeom>
+          <a:noFill/>
+          <a:ln w="22225">
+            <a:solidFill>
+              <a:srgbClr val="404040"/>
+            </a:solidFill>
+          </a:ln>
+        </p:spPr>
+        <p:txBody>
+          <a:bodyPr/>
+          <a:lstStyle/>
+          <a:p>
+            <a:endParaRPr lang="pl-PL"/>
+          </a:p>
+        </p:txBody>
+      </p:sp>
+      <p:sp>
+        <p:nvSpPr>
+          <p:cNvPr id="108" name="Element 108"/>
+          <p:cNvSpPr/>
+          <p:nvPr/>
+        </p:nvSpPr>
+        <p:spPr>
+          <a:xfrm>
+            <a:off x="10332720" y="3108960"/>
+            <a:ext cx="365760" cy="457200"/>
+          </a:xfrm>
+          <a:prstGeom prst="rect">
+            <a:avLst/>
+          </a:prstGeom>
+          <a:noFill/>
+          <a:ln w="22225">
+            <a:solidFill>
+              <a:srgbClr val="404040"/>
+            </a:solidFill>
+          </a:ln>
+        </p:spPr>
+        <p:txBody>
+          <a:bodyPr/>
+          <a:lstStyle/>
+          <a:p>
+            <a:endParaRPr lang="pl-PL"/>
+          </a:p>
+        </p:txBody>
+      </p:sp>
+      <p:sp>
+        <p:nvSpPr>
+          <p:cNvPr id="109" name="Element 109"/>
+          <p:cNvSpPr/>
+          <p:nvPr/>
+        </p:nvSpPr>
+        <p:spPr>
+          <a:xfrm>
+            <a:off x="10287000" y="2880360"/>
+            <a:ext cx="457200" cy="228600"/>
+          </a:xfrm>
+          <a:prstGeom prst="rect">
+            <a:avLst/>
+          </a:prstGeom>
+          <a:solidFill>
+            <a:srgbClr val="E3B18D"/>
+          </a:solidFill>
+          <a:ln>
+            <a:noFill/>
+          </a:ln>
+        </p:spPr>
+        <p:txBody>
+          <a:bodyPr/>
+          <a:lstStyle/>
+          <a:p>
+            <a:endParaRPr lang="pl-PL"/>
+          </a:p>
+        </p:txBody>
+      </p:sp>
+      <p:sp>
+        <p:nvSpPr>
+          <p:cNvPr id="110" name="Element 110"/>
+          <p:cNvSpPr/>
+          <p:nvPr/>
+        </p:nvSpPr>
+        <p:spPr>
+          <a:xfrm>
+            <a:off x="9875520" y="5120640"/>
+            <a:ext cx="1280160" cy="365760"/>
+          </a:xfrm>
+          <a:prstGeom prst="rect">
+            <a:avLst/>
+          </a:prstGeom>
+          <a:noFill/>
+          <a:ln>
+            <a:noFill/>
+          </a:ln>
+        </p:spPr>
+        <p:txBody>
+          <a:bodyPr wrap="square" lIns="0" tIns="0" rIns="0" bIns="0" anchor="ctr">
+            <a:noAutofit/>
+          </a:bodyPr>
+          <a:lstStyle/>
+          <a:p>
+            <a:pPr algn="ctr"/>
+            <a:r>
+              <a:rPr lang="pl-PL" sz="1600" b="0" dirty="0">
+                <a:solidFill>
+                  <a:srgbClr val="8A8A8A"/>
+                </a:solidFill>
+                <a:latin typeface="+mn-lt"/>
+              </a:rPr>
+              <a:t>produkt</a:t>
+            </a:r>
+          </a:p>
+        </p:txBody>
+      </p:sp>
     </p:spTree>
     <p:extLst>
       <p:ext uri="{BB962C8B-B14F-4D97-AF65-F5344CB8AC3E}">
@@ -21868,6 +24559,291 @@
           </a:p>
         </p:txBody>
       </p:sp>
+      <p:sp>
+        <p:nvSpPr>
+          <p:cNvPr id="101" name="Element 101"/>
+          <p:cNvSpPr/>
+          <p:nvPr/>
+        </p:nvSpPr>
+        <p:spPr>
+          <a:xfrm>
+            <a:off x="6309360" y="2011680"/>
+            <a:ext cx="2377440" cy="2103120"/>
+          </a:xfrm>
+          <a:prstGeom prst="triangle">
+            <a:avLst/>
+          </a:prstGeom>
+          <a:noFill/>
+          <a:ln w="38100">
+            <a:solidFill>
+              <a:srgbClr val="E3B18D"/>
+            </a:solidFill>
+          </a:ln>
+        </p:spPr>
+        <p:txBody>
+          <a:bodyPr/>
+          <a:lstStyle/>
+          <a:p>
+            <a:endParaRPr lang="pl-PL"/>
+          </a:p>
+        </p:txBody>
+      </p:sp>
+      <p:sp>
+        <p:nvSpPr>
+          <p:cNvPr id="102" name="Element 102"/>
+          <p:cNvSpPr/>
+          <p:nvPr/>
+        </p:nvSpPr>
+        <p:spPr>
+          <a:xfrm>
+            <a:off x="7223760" y="2926080"/>
+            <a:ext cx="548640" cy="822960"/>
+          </a:xfrm>
+          <a:prstGeom prst="rect">
+            <a:avLst/>
+          </a:prstGeom>
+          <a:noFill/>
+          <a:ln>
+            <a:noFill/>
+          </a:ln>
+        </p:spPr>
+        <p:txBody>
+          <a:bodyPr wrap="square" lIns="0" tIns="0" rIns="0" bIns="0" anchor="ctr">
+            <a:noAutofit/>
+          </a:bodyPr>
+          <a:lstStyle/>
+          <a:p>
+            <a:pPr algn="ctr"/>
+            <a:r>
+              <a:rPr lang="pl-PL" sz="4800" b="1" dirty="0">
+                <a:solidFill>
+                  <a:srgbClr val="404040"/>
+                </a:solidFill>
+                <a:latin typeface="+mn-lt"/>
+              </a:rPr>
+              <a:t>!</a:t>
+            </a:r>
+          </a:p>
+        </p:txBody>
+      </p:sp>
+      <p:cxnSp>
+        <p:nvCxnSpPr>
+          <p:cNvPr id="103" name="Linia 103"/>
+          <p:cNvCxnSpPr/>
+          <p:nvPr/>
+        </p:nvCxnSpPr>
+        <p:spPr>
+          <a:xfrm>
+            <a:off x="10058400" y="2194560"/>
+            <a:ext cx="0" cy="1920240"/>
+          </a:xfrm>
+          <a:prstGeom prst="line">
+            <a:avLst/>
+          </a:prstGeom>
+          <a:ln w="25400">
+            <a:solidFill>
+              <a:srgbClr val="404040"/>
+            </a:solidFill>
+          </a:ln>
+        </p:spPr>
+      </p:cxnSp>
+      <p:cxnSp>
+        <p:nvCxnSpPr>
+          <p:cNvPr id="104" name="Linia 104"/>
+          <p:cNvCxnSpPr/>
+          <p:nvPr/>
+        </p:nvCxnSpPr>
+        <p:spPr>
+          <a:xfrm flipV="1">
+            <a:off x="9326880" y="4114800"/>
+            <a:ext cx="731520" cy="914400"/>
+          </a:xfrm>
+          <a:prstGeom prst="line">
+            <a:avLst/>
+          </a:prstGeom>
+          <a:ln w="25400">
+            <a:solidFill>
+              <a:srgbClr val="404040"/>
+            </a:solidFill>
+          </a:ln>
+        </p:spPr>
+      </p:cxnSp>
+      <p:cxnSp>
+        <p:nvCxnSpPr>
+          <p:cNvPr id="105" name="Linia 105"/>
+          <p:cNvCxnSpPr/>
+          <p:nvPr/>
+        </p:nvCxnSpPr>
+        <p:spPr>
+          <a:xfrm>
+            <a:off x="10058400" y="4114800"/>
+            <a:ext cx="731520" cy="914400"/>
+          </a:xfrm>
+          <a:prstGeom prst="line">
+            <a:avLst/>
+          </a:prstGeom>
+          <a:ln w="25400">
+            <a:solidFill>
+              <a:srgbClr val="404040"/>
+            </a:solidFill>
+          </a:ln>
+        </p:spPr>
+      </p:cxnSp>
+      <p:cxnSp>
+        <p:nvCxnSpPr>
+          <p:cNvPr id="106" name="Linia 106"/>
+          <p:cNvCxnSpPr/>
+          <p:nvPr/>
+        </p:nvCxnSpPr>
+        <p:spPr>
+          <a:xfrm>
+            <a:off x="10058400" y="4114800"/>
+            <a:ext cx="0" cy="914400"/>
+          </a:xfrm>
+          <a:prstGeom prst="line">
+            <a:avLst/>
+          </a:prstGeom>
+          <a:ln w="25400">
+            <a:solidFill>
+              <a:srgbClr val="404040"/>
+            </a:solidFill>
+          </a:ln>
+        </p:spPr>
+      </p:cxnSp>
+      <p:sp>
+        <p:nvSpPr>
+          <p:cNvPr id="107" name="Element 107"/>
+          <p:cNvSpPr/>
+          <p:nvPr/>
+        </p:nvSpPr>
+        <p:spPr>
+          <a:xfrm>
+            <a:off x="9738360" y="1828800"/>
+            <a:ext cx="640080" cy="457200"/>
+          </a:xfrm>
+          <a:prstGeom prst="roundRect">
+            <a:avLst/>
+          </a:prstGeom>
+          <a:solidFill>
+            <a:srgbClr val="E3B18D"/>
+          </a:solidFill>
+          <a:ln>
+            <a:noFill/>
+          </a:ln>
+        </p:spPr>
+        <p:txBody>
+          <a:bodyPr/>
+          <a:lstStyle/>
+          <a:p>
+            <a:endParaRPr lang="pl-PL"/>
+          </a:p>
+        </p:txBody>
+      </p:sp>
+      <p:sp>
+        <p:nvSpPr>
+          <p:cNvPr id="108" name="Element 108"/>
+          <p:cNvSpPr/>
+          <p:nvPr/>
+        </p:nvSpPr>
+        <p:spPr>
+          <a:xfrm>
+            <a:off x="9784080" y="4663440"/>
+            <a:ext cx="548640" cy="365760"/>
+          </a:xfrm>
+          <a:prstGeom prst="rect">
+            <a:avLst/>
+          </a:prstGeom>
+          <a:solidFill>
+            <a:srgbClr val="404040"/>
+          </a:solidFill>
+          <a:ln>
+            <a:noFill/>
+          </a:ln>
+        </p:spPr>
+        <p:txBody>
+          <a:bodyPr/>
+          <a:lstStyle/>
+          <a:p>
+            <a:endParaRPr lang="pl-PL"/>
+          </a:p>
+        </p:txBody>
+      </p:sp>
+      <p:sp>
+        <p:nvSpPr>
+          <p:cNvPr id="109" name="Element 109"/>
+          <p:cNvSpPr/>
+          <p:nvPr/>
+        </p:nvSpPr>
+        <p:spPr>
+          <a:xfrm>
+            <a:off x="8869680" y="5166360"/>
+            <a:ext cx="2377440" cy="365760"/>
+          </a:xfrm>
+          <a:prstGeom prst="rect">
+            <a:avLst/>
+          </a:prstGeom>
+          <a:noFill/>
+          <a:ln>
+            <a:noFill/>
+          </a:ln>
+        </p:spPr>
+        <p:txBody>
+          <a:bodyPr wrap="square" lIns="0" tIns="0" rIns="0" bIns="0" anchor="ctr">
+            <a:noAutofit/>
+          </a:bodyPr>
+          <a:lstStyle/>
+          <a:p>
+            <a:pPr algn="ctr"/>
+            <a:r>
+              <a:rPr lang="pl-PL" sz="1400" b="0" dirty="0">
+                <a:solidFill>
+                  <a:srgbClr val="8A8A8A"/>
+                </a:solidFill>
+                <a:latin typeface="+mn-lt"/>
+              </a:rPr>
+              <a:t>statyw + obciążenie</a:t>
+            </a:r>
+          </a:p>
+        </p:txBody>
+      </p:sp>
+      <p:sp>
+        <p:nvSpPr>
+          <p:cNvPr id="110" name="Element 110"/>
+          <p:cNvSpPr/>
+          <p:nvPr/>
+        </p:nvSpPr>
+        <p:spPr>
+          <a:xfrm>
+            <a:off x="6309360" y="4297680"/>
+            <a:ext cx="2377440" cy="365760"/>
+          </a:xfrm>
+          <a:prstGeom prst="rect">
+            <a:avLst/>
+          </a:prstGeom>
+          <a:noFill/>
+          <a:ln>
+            <a:noFill/>
+          </a:ln>
+        </p:spPr>
+        <p:txBody>
+          <a:bodyPr wrap="square" lIns="0" tIns="0" rIns="0" bIns="0" anchor="ctr">
+            <a:noAutofit/>
+          </a:bodyPr>
+          <a:lstStyle/>
+          <a:p>
+            <a:pPr algn="ctr"/>
+            <a:r>
+              <a:rPr lang="pl-PL" sz="1400" b="0" dirty="0">
+                <a:solidFill>
+                  <a:srgbClr val="8A8A8A"/>
+                </a:solidFill>
+                <a:latin typeface="+mn-lt"/>
+              </a:rPr>
+              <a:t>uwaga na planie</a:t>
+            </a:r>
+          </a:p>
+        </p:txBody>
+      </p:sp>
     </p:spTree>
     <p:extLst>
       <p:ext uri="{BB962C8B-B14F-4D97-AF65-F5344CB8AC3E}">
@@ -21903,169 +24879,6 @@
           <p:cNvPr id="2" name="Title 1">
             <a:extLst>
               <a:ext uri="{FF2B5EF4-FFF2-40B4-BE49-F238E27FC236}">
-                <a16:creationId xmlns:a16="http://schemas.microsoft.com/office/drawing/2014/main" id="{1CD9B74B-BCF9-74DD-59F5-DE82981A3EFA}"/>
-              </a:ext>
-            </a:extLst>
-          </p:cNvPr>
-          <p:cNvSpPr>
-            <a:spLocks noGrp="1"/>
-          </p:cNvSpPr>
-          <p:nvPr>
-            <p:ph type="title"/>
-          </p:nvPr>
-        </p:nvSpPr>
-        <p:spPr/>
-        <p:txBody>
-          <a:bodyPr/>
-          <a:lstStyle/>
-          <a:p>
-            <a:r>
-              <a:rPr lang="pl-PL" dirty="0"/>
-              <a:t>Namiot bezcieniowy</a:t>
-            </a:r>
-          </a:p>
-        </p:txBody>
-      </p:sp>
-      <p:sp>
-        <p:nvSpPr>
-          <p:cNvPr id="3" name="Content Placeholder 2">
-            <a:extLst>
-              <a:ext uri="{FF2B5EF4-FFF2-40B4-BE49-F238E27FC236}">
-                <a16:creationId xmlns:a16="http://schemas.microsoft.com/office/drawing/2014/main" id="{6BBE3872-89CF-01FA-8AF7-B426CD334D6E}"/>
-              </a:ext>
-            </a:extLst>
-          </p:cNvPr>
-          <p:cNvSpPr>
-            <a:spLocks noGrp="1"/>
-          </p:cNvSpPr>
-          <p:nvPr>
-            <p:ph idx="1"/>
-          </p:nvPr>
-        </p:nvSpPr>
-        <p:spPr/>
-        <p:txBody>
-          <a:bodyPr/>
-          <a:lstStyle/>
-          <a:p>
-            <a:r>
-              <a:rPr lang="pl-PL" dirty="0"/>
-              <a:t>Ogranicza niechciane odbicia</a:t>
-            </a:r>
-          </a:p>
-          <a:p>
-            <a:r>
-              <a:rPr lang="pl-PL" dirty="0"/>
-              <a:t>Ułatwia fotografię flakonów i słoiczków</a:t>
-            </a:r>
-          </a:p>
-          <a:p>
-            <a:r>
-              <a:rPr lang="pl-PL" dirty="0"/>
-              <a:t>Daje powtarzalny efekt</a:t>
-            </a:r>
-          </a:p>
-          <a:p>
-            <a:r>
-              <a:rPr lang="pl-PL" dirty="0"/>
-              <a:t>Mniej retuszu</a:t>
-            </a:r>
-          </a:p>
-        </p:txBody>
-      </p:sp>
-      <p:sp>
-        <p:nvSpPr>
-          <p:cNvPr id="4" name="Footer Placeholder 3">
-            <a:extLst>
-              <a:ext uri="{FF2B5EF4-FFF2-40B4-BE49-F238E27FC236}">
-                <a16:creationId xmlns:a16="http://schemas.microsoft.com/office/drawing/2014/main" id="{FA4C72CD-79CB-93DA-2519-5E89D9121506}"/>
-              </a:ext>
-            </a:extLst>
-          </p:cNvPr>
-          <p:cNvSpPr>
-            <a:spLocks noGrp="1"/>
-          </p:cNvSpPr>
-          <p:nvPr>
-            <p:ph type="ftr" sz="quarter" idx="11"/>
-          </p:nvPr>
-        </p:nvSpPr>
-        <p:spPr/>
-        <p:txBody>
-          <a:bodyPr/>
-          <a:lstStyle/>
-          <a:p>
-            <a:pPr rtl="0"/>
-            <a:r>
-              <a:rPr lang="pl-PL" dirty="0"/>
-              <a:t>Światło jako narzędzie pracy</a:t>
-            </a:r>
-          </a:p>
-        </p:txBody>
-      </p:sp>
-      <p:sp>
-        <p:nvSpPr>
-          <p:cNvPr id="5" name="Slide Number Placeholder 4">
-            <a:extLst>
-              <a:ext uri="{FF2B5EF4-FFF2-40B4-BE49-F238E27FC236}">
-                <a16:creationId xmlns:a16="http://schemas.microsoft.com/office/drawing/2014/main" id="{E8F8C5C5-4DE5-1431-46B2-9942F962D8FB}"/>
-              </a:ext>
-            </a:extLst>
-          </p:cNvPr>
-          <p:cNvSpPr>
-            <a:spLocks noGrp="1"/>
-          </p:cNvSpPr>
-          <p:nvPr>
-            <p:ph type="sldNum" sz="quarter" idx="12"/>
-          </p:nvPr>
-        </p:nvSpPr>
-        <p:spPr/>
-        <p:txBody>
-          <a:bodyPr/>
-          <a:lstStyle/>
-          <a:p>
-            <a:pPr rtl="0"/>
-            <a:fld id="{B5CEABB6-07DC-46E8-9B57-56EC44A396E5}" type="slidenum">
-              <a:rPr lang="pl-PL" noProof="0" smtClean="0"/>
-              <a:t>13</a:t>
-            </a:fld>
-            <a:endParaRPr lang="pl-PL" noProof="0"/>
-          </a:p>
-        </p:txBody>
-      </p:sp>
-    </p:spTree>
-    <p:extLst>
-      <p:ext uri="{BB962C8B-B14F-4D97-AF65-F5344CB8AC3E}">
-        <p14:creationId xmlns:p14="http://schemas.microsoft.com/office/powerpoint/2010/main" val="1322217404"/>
-      </p:ext>
-    </p:extLst>
-  </p:cSld>
-  <p:clrMapOvr>
-    <a:masterClrMapping/>
-  </p:clrMapOvr>
-</p:sld>
-</file>
-
-<file path=ppt/slides/slide23.xml><?xml version="1.0" encoding="utf-8"?>
-<p:sld xmlns:a="http://schemas.openxmlformats.org/drawingml/2006/main" xmlns:r="http://schemas.openxmlformats.org/officeDocument/2006/relationships" xmlns:p="http://schemas.openxmlformats.org/presentationml/2006/main">
-  <p:cSld>
-    <p:spTree>
-      <p:nvGrpSpPr>
-        <p:cNvPr id="1" name=""/>
-        <p:cNvGrpSpPr/>
-        <p:nvPr/>
-      </p:nvGrpSpPr>
-      <p:grpSpPr>
-        <a:xfrm>
-          <a:off x="0" y="0"/>
-          <a:ext cx="0" cy="0"/>
-          <a:chOff x="0" y="0"/>
-          <a:chExt cx="0" cy="0"/>
-        </a:xfrm>
-      </p:grpSpPr>
-      <p:sp>
-        <p:nvSpPr>
-          <p:cNvPr id="2" name="Title 1">
-            <a:extLst>
-              <a:ext uri="{FF2B5EF4-FFF2-40B4-BE49-F238E27FC236}">
                 <a16:creationId xmlns:a16="http://schemas.microsoft.com/office/drawing/2014/main" id="{73DC2645-5EBF-48C5-3B87-093699F4D1AC}"/>
               </a:ext>
             </a:extLst>
@@ -22191,6 +25004,708 @@
               <a:t>19</a:t>
             </a:fld>
             <a:endParaRPr lang="pl-PL" noProof="0"/>
+          </a:p>
+        </p:txBody>
+      </p:sp>
+      <p:sp>
+        <p:nvSpPr>
+          <p:cNvPr id="101" name="Element 101"/>
+          <p:cNvSpPr/>
+          <p:nvPr/>
+        </p:nvSpPr>
+        <p:spPr>
+          <a:xfrm>
+            <a:off x="6126480" y="2103120"/>
+            <a:ext cx="1188720" cy="1463040"/>
+          </a:xfrm>
+          <a:prstGeom prst="rect">
+            <a:avLst/>
+          </a:prstGeom>
+          <a:noFill/>
+          <a:ln w="19050">
+            <a:solidFill>
+              <a:srgbClr val="E3B18D"/>
+            </a:solidFill>
+          </a:ln>
+        </p:spPr>
+        <p:txBody>
+          <a:bodyPr/>
+          <a:lstStyle/>
+          <a:p>
+            <a:endParaRPr lang="pl-PL"/>
+          </a:p>
+        </p:txBody>
+      </p:sp>
+      <p:sp>
+        <p:nvSpPr>
+          <p:cNvPr id="102" name="Element 102"/>
+          <p:cNvSpPr/>
+          <p:nvPr/>
+        </p:nvSpPr>
+        <p:spPr>
+          <a:xfrm>
+            <a:off x="6446520" y="2468880"/>
+            <a:ext cx="548640" cy="548640"/>
+          </a:xfrm>
+          <a:prstGeom prst="ellipse">
+            <a:avLst/>
+          </a:prstGeom>
+          <a:solidFill>
+            <a:srgbClr val="E3B18D"/>
+          </a:solidFill>
+          <a:ln>
+            <a:noFill/>
+          </a:ln>
+        </p:spPr>
+        <p:txBody>
+          <a:bodyPr/>
+          <a:lstStyle/>
+          <a:p>
+            <a:endParaRPr lang="pl-PL"/>
+          </a:p>
+        </p:txBody>
+      </p:sp>
+      <p:cxnSp>
+        <p:nvCxnSpPr>
+          <p:cNvPr id="103" name="Linia 103"/>
+          <p:cNvCxnSpPr/>
+          <p:nvPr/>
+        </p:nvCxnSpPr>
+        <p:spPr>
+          <a:xfrm>
+            <a:off x="6309360" y="3291840"/>
+            <a:ext cx="822960" cy="0"/>
+          </a:xfrm>
+          <a:prstGeom prst="line">
+            <a:avLst/>
+          </a:prstGeom>
+          <a:ln w="15875">
+            <a:solidFill>
+              <a:srgbClr val="404040"/>
+            </a:solidFill>
+          </a:ln>
+        </p:spPr>
+      </p:cxnSp>
+      <p:sp>
+        <p:nvSpPr>
+          <p:cNvPr id="104" name="Element 104"/>
+          <p:cNvSpPr/>
+          <p:nvPr/>
+        </p:nvSpPr>
+        <p:spPr>
+          <a:xfrm>
+            <a:off x="6217920" y="3749040"/>
+            <a:ext cx="320040" cy="320040"/>
+          </a:xfrm>
+          <a:prstGeom prst="rect">
+            <a:avLst/>
+          </a:prstGeom>
+          <a:solidFill>
+            <a:srgbClr val="E3B18D"/>
+          </a:solidFill>
+          <a:ln>
+            <a:noFill/>
+          </a:ln>
+        </p:spPr>
+        <p:txBody>
+          <a:bodyPr/>
+          <a:lstStyle/>
+          <a:p>
+            <a:endParaRPr lang="pl-PL"/>
+          </a:p>
+        </p:txBody>
+      </p:sp>
+      <p:sp>
+        <p:nvSpPr>
+          <p:cNvPr id="105" name="Element 105"/>
+          <p:cNvSpPr/>
+          <p:nvPr/>
+        </p:nvSpPr>
+        <p:spPr>
+          <a:xfrm>
+            <a:off x="6583680" y="3749040"/>
+            <a:ext cx="320040" cy="320040"/>
+          </a:xfrm>
+          <a:prstGeom prst="rect">
+            <a:avLst/>
+          </a:prstGeom>
+          <a:solidFill>
+            <a:srgbClr val="404040"/>
+          </a:solidFill>
+          <a:ln>
+            <a:noFill/>
+          </a:ln>
+        </p:spPr>
+        <p:txBody>
+          <a:bodyPr/>
+          <a:lstStyle/>
+          <a:p>
+            <a:endParaRPr lang="pl-PL"/>
+          </a:p>
+        </p:txBody>
+      </p:sp>
+      <p:sp>
+        <p:nvSpPr>
+          <p:cNvPr id="106" name="Element 106"/>
+          <p:cNvSpPr/>
+          <p:nvPr/>
+        </p:nvSpPr>
+        <p:spPr>
+          <a:xfrm>
+            <a:off x="6949440" y="3749040"/>
+            <a:ext cx="320040" cy="320040"/>
+          </a:xfrm>
+          <a:prstGeom prst="rect">
+            <a:avLst/>
+          </a:prstGeom>
+          <a:solidFill>
+            <a:srgbClr val="C9CDD2"/>
+          </a:solidFill>
+          <a:ln>
+            <a:noFill/>
+          </a:ln>
+        </p:spPr>
+        <p:txBody>
+          <a:bodyPr/>
+          <a:lstStyle/>
+          <a:p>
+            <a:endParaRPr lang="pl-PL"/>
+          </a:p>
+        </p:txBody>
+      </p:sp>
+      <p:sp>
+        <p:nvSpPr>
+          <p:cNvPr id="107" name="Element 107"/>
+          <p:cNvSpPr/>
+          <p:nvPr/>
+        </p:nvSpPr>
+        <p:spPr>
+          <a:xfrm>
+            <a:off x="7498080" y="2103120"/>
+            <a:ext cx="1188720" cy="1463040"/>
+          </a:xfrm>
+          <a:prstGeom prst="rect">
+            <a:avLst/>
+          </a:prstGeom>
+          <a:noFill/>
+          <a:ln w="19050">
+            <a:solidFill>
+              <a:srgbClr val="E3B18D"/>
+            </a:solidFill>
+          </a:ln>
+        </p:spPr>
+        <p:txBody>
+          <a:bodyPr/>
+          <a:lstStyle/>
+          <a:p>
+            <a:endParaRPr lang="pl-PL"/>
+          </a:p>
+        </p:txBody>
+      </p:sp>
+      <p:sp>
+        <p:nvSpPr>
+          <p:cNvPr id="108" name="Element 108"/>
+          <p:cNvSpPr/>
+          <p:nvPr/>
+        </p:nvSpPr>
+        <p:spPr>
+          <a:xfrm>
+            <a:off x="7818120" y="2468880"/>
+            <a:ext cx="548640" cy="548640"/>
+          </a:xfrm>
+          <a:prstGeom prst="ellipse">
+            <a:avLst/>
+          </a:prstGeom>
+          <a:solidFill>
+            <a:srgbClr val="E3B18D"/>
+          </a:solidFill>
+          <a:ln>
+            <a:noFill/>
+          </a:ln>
+        </p:spPr>
+        <p:txBody>
+          <a:bodyPr/>
+          <a:lstStyle/>
+          <a:p>
+            <a:endParaRPr lang="pl-PL"/>
+          </a:p>
+        </p:txBody>
+      </p:sp>
+      <p:cxnSp>
+        <p:nvCxnSpPr>
+          <p:cNvPr id="109" name="Linia 109"/>
+          <p:cNvCxnSpPr/>
+          <p:nvPr/>
+        </p:nvCxnSpPr>
+        <p:spPr>
+          <a:xfrm>
+            <a:off x="7680960" y="3291840"/>
+            <a:ext cx="822960" cy="0"/>
+          </a:xfrm>
+          <a:prstGeom prst="line">
+            <a:avLst/>
+          </a:prstGeom>
+          <a:ln w="15875">
+            <a:solidFill>
+              <a:srgbClr val="404040"/>
+            </a:solidFill>
+          </a:ln>
+        </p:spPr>
+      </p:cxnSp>
+      <p:sp>
+        <p:nvSpPr>
+          <p:cNvPr id="110" name="Element 110"/>
+          <p:cNvSpPr/>
+          <p:nvPr/>
+        </p:nvSpPr>
+        <p:spPr>
+          <a:xfrm>
+            <a:off x="7589520" y="3749040"/>
+            <a:ext cx="320040" cy="320040"/>
+          </a:xfrm>
+          <a:prstGeom prst="rect">
+            <a:avLst/>
+          </a:prstGeom>
+          <a:solidFill>
+            <a:srgbClr val="E3B18D"/>
+          </a:solidFill>
+          <a:ln>
+            <a:noFill/>
+          </a:ln>
+        </p:spPr>
+        <p:txBody>
+          <a:bodyPr/>
+          <a:lstStyle/>
+          <a:p>
+            <a:endParaRPr lang="pl-PL"/>
+          </a:p>
+        </p:txBody>
+      </p:sp>
+      <p:sp>
+        <p:nvSpPr>
+          <p:cNvPr id="111" name="Element 111"/>
+          <p:cNvSpPr/>
+          <p:nvPr/>
+        </p:nvSpPr>
+        <p:spPr>
+          <a:xfrm>
+            <a:off x="7955280" y="3749040"/>
+            <a:ext cx="320040" cy="320040"/>
+          </a:xfrm>
+          <a:prstGeom prst="rect">
+            <a:avLst/>
+          </a:prstGeom>
+          <a:solidFill>
+            <a:srgbClr val="404040"/>
+          </a:solidFill>
+          <a:ln>
+            <a:noFill/>
+          </a:ln>
+        </p:spPr>
+        <p:txBody>
+          <a:bodyPr/>
+          <a:lstStyle/>
+          <a:p>
+            <a:endParaRPr lang="pl-PL"/>
+          </a:p>
+        </p:txBody>
+      </p:sp>
+      <p:sp>
+        <p:nvSpPr>
+          <p:cNvPr id="112" name="Element 112"/>
+          <p:cNvSpPr/>
+          <p:nvPr/>
+        </p:nvSpPr>
+        <p:spPr>
+          <a:xfrm>
+            <a:off x="8321040" y="3749040"/>
+            <a:ext cx="320040" cy="320040"/>
+          </a:xfrm>
+          <a:prstGeom prst="rect">
+            <a:avLst/>
+          </a:prstGeom>
+          <a:solidFill>
+            <a:srgbClr val="C9CDD2"/>
+          </a:solidFill>
+          <a:ln>
+            <a:noFill/>
+          </a:ln>
+        </p:spPr>
+        <p:txBody>
+          <a:bodyPr/>
+          <a:lstStyle/>
+          <a:p>
+            <a:endParaRPr lang="pl-PL"/>
+          </a:p>
+        </p:txBody>
+      </p:sp>
+      <p:sp>
+        <p:nvSpPr>
+          <p:cNvPr id="113" name="Element 113"/>
+          <p:cNvSpPr/>
+          <p:nvPr/>
+        </p:nvSpPr>
+        <p:spPr>
+          <a:xfrm>
+            <a:off x="8869680" y="2103120"/>
+            <a:ext cx="1188720" cy="1463040"/>
+          </a:xfrm>
+          <a:prstGeom prst="rect">
+            <a:avLst/>
+          </a:prstGeom>
+          <a:noFill/>
+          <a:ln w="19050">
+            <a:solidFill>
+              <a:srgbClr val="E3B18D"/>
+            </a:solidFill>
+          </a:ln>
+        </p:spPr>
+        <p:txBody>
+          <a:bodyPr/>
+          <a:lstStyle/>
+          <a:p>
+            <a:endParaRPr lang="pl-PL"/>
+          </a:p>
+        </p:txBody>
+      </p:sp>
+      <p:sp>
+        <p:nvSpPr>
+          <p:cNvPr id="114" name="Element 114"/>
+          <p:cNvSpPr/>
+          <p:nvPr/>
+        </p:nvSpPr>
+        <p:spPr>
+          <a:xfrm>
+            <a:off x="9189720" y="2468880"/>
+            <a:ext cx="548640" cy="548640"/>
+          </a:xfrm>
+          <a:prstGeom prst="ellipse">
+            <a:avLst/>
+          </a:prstGeom>
+          <a:solidFill>
+            <a:srgbClr val="E3B18D"/>
+          </a:solidFill>
+          <a:ln>
+            <a:noFill/>
+          </a:ln>
+        </p:spPr>
+        <p:txBody>
+          <a:bodyPr/>
+          <a:lstStyle/>
+          <a:p>
+            <a:endParaRPr lang="pl-PL"/>
+          </a:p>
+        </p:txBody>
+      </p:sp>
+      <p:cxnSp>
+        <p:nvCxnSpPr>
+          <p:cNvPr id="115" name="Linia 115"/>
+          <p:cNvCxnSpPr/>
+          <p:nvPr/>
+        </p:nvCxnSpPr>
+        <p:spPr>
+          <a:xfrm>
+            <a:off x="9052560" y="3291840"/>
+            <a:ext cx="822960" cy="0"/>
+          </a:xfrm>
+          <a:prstGeom prst="line">
+            <a:avLst/>
+          </a:prstGeom>
+          <a:ln w="15875">
+            <a:solidFill>
+              <a:srgbClr val="404040"/>
+            </a:solidFill>
+          </a:ln>
+        </p:spPr>
+      </p:cxnSp>
+      <p:sp>
+        <p:nvSpPr>
+          <p:cNvPr id="116" name="Element 116"/>
+          <p:cNvSpPr/>
+          <p:nvPr/>
+        </p:nvSpPr>
+        <p:spPr>
+          <a:xfrm>
+            <a:off x="8961120" y="3749040"/>
+            <a:ext cx="320040" cy="320040"/>
+          </a:xfrm>
+          <a:prstGeom prst="rect">
+            <a:avLst/>
+          </a:prstGeom>
+          <a:solidFill>
+            <a:srgbClr val="E3B18D"/>
+          </a:solidFill>
+          <a:ln>
+            <a:noFill/>
+          </a:ln>
+        </p:spPr>
+        <p:txBody>
+          <a:bodyPr/>
+          <a:lstStyle/>
+          <a:p>
+            <a:endParaRPr lang="pl-PL"/>
+          </a:p>
+        </p:txBody>
+      </p:sp>
+      <p:sp>
+        <p:nvSpPr>
+          <p:cNvPr id="117" name="Element 117"/>
+          <p:cNvSpPr/>
+          <p:nvPr/>
+        </p:nvSpPr>
+        <p:spPr>
+          <a:xfrm>
+            <a:off x="9326880" y="3749040"/>
+            <a:ext cx="320040" cy="320040"/>
+          </a:xfrm>
+          <a:prstGeom prst="rect">
+            <a:avLst/>
+          </a:prstGeom>
+          <a:solidFill>
+            <a:srgbClr val="404040"/>
+          </a:solidFill>
+          <a:ln>
+            <a:noFill/>
+          </a:ln>
+        </p:spPr>
+        <p:txBody>
+          <a:bodyPr/>
+          <a:lstStyle/>
+          <a:p>
+            <a:endParaRPr lang="pl-PL"/>
+          </a:p>
+        </p:txBody>
+      </p:sp>
+      <p:sp>
+        <p:nvSpPr>
+          <p:cNvPr id="118" name="Element 118"/>
+          <p:cNvSpPr/>
+          <p:nvPr/>
+        </p:nvSpPr>
+        <p:spPr>
+          <a:xfrm>
+            <a:off x="9692640" y="3749040"/>
+            <a:ext cx="320040" cy="320040"/>
+          </a:xfrm>
+          <a:prstGeom prst="rect">
+            <a:avLst/>
+          </a:prstGeom>
+          <a:solidFill>
+            <a:srgbClr val="C9CDD2"/>
+          </a:solidFill>
+          <a:ln>
+            <a:noFill/>
+          </a:ln>
+        </p:spPr>
+        <p:txBody>
+          <a:bodyPr/>
+          <a:lstStyle/>
+          <a:p>
+            <a:endParaRPr lang="pl-PL"/>
+          </a:p>
+        </p:txBody>
+      </p:sp>
+      <p:sp>
+        <p:nvSpPr>
+          <p:cNvPr id="119" name="Element 119"/>
+          <p:cNvSpPr/>
+          <p:nvPr/>
+        </p:nvSpPr>
+        <p:spPr>
+          <a:xfrm>
+            <a:off x="10241280" y="2103120"/>
+            <a:ext cx="1188720" cy="1463040"/>
+          </a:xfrm>
+          <a:prstGeom prst="rect">
+            <a:avLst/>
+          </a:prstGeom>
+          <a:noFill/>
+          <a:ln w="19050">
+            <a:solidFill>
+              <a:srgbClr val="E3B18D"/>
+            </a:solidFill>
+          </a:ln>
+        </p:spPr>
+        <p:txBody>
+          <a:bodyPr/>
+          <a:lstStyle/>
+          <a:p>
+            <a:endParaRPr lang="pl-PL"/>
+          </a:p>
+        </p:txBody>
+      </p:sp>
+      <p:sp>
+        <p:nvSpPr>
+          <p:cNvPr id="120" name="Element 120"/>
+          <p:cNvSpPr/>
+          <p:nvPr/>
+        </p:nvSpPr>
+        <p:spPr>
+          <a:xfrm>
+            <a:off x="10561320" y="2468880"/>
+            <a:ext cx="548640" cy="548640"/>
+          </a:xfrm>
+          <a:prstGeom prst="ellipse">
+            <a:avLst/>
+          </a:prstGeom>
+          <a:solidFill>
+            <a:srgbClr val="E3B18D"/>
+          </a:solidFill>
+          <a:ln>
+            <a:noFill/>
+          </a:ln>
+        </p:spPr>
+        <p:txBody>
+          <a:bodyPr/>
+          <a:lstStyle/>
+          <a:p>
+            <a:endParaRPr lang="pl-PL"/>
+          </a:p>
+        </p:txBody>
+      </p:sp>
+      <p:cxnSp>
+        <p:nvCxnSpPr>
+          <p:cNvPr id="121" name="Linia 121"/>
+          <p:cNvCxnSpPr/>
+          <p:nvPr/>
+        </p:nvCxnSpPr>
+        <p:spPr>
+          <a:xfrm>
+            <a:off x="10424160" y="3291840"/>
+            <a:ext cx="822960" cy="0"/>
+          </a:xfrm>
+          <a:prstGeom prst="line">
+            <a:avLst/>
+          </a:prstGeom>
+          <a:ln w="15875">
+            <a:solidFill>
+              <a:srgbClr val="404040"/>
+            </a:solidFill>
+          </a:ln>
+        </p:spPr>
+      </p:cxnSp>
+      <p:sp>
+        <p:nvSpPr>
+          <p:cNvPr id="122" name="Element 122"/>
+          <p:cNvSpPr/>
+          <p:nvPr/>
+        </p:nvSpPr>
+        <p:spPr>
+          <a:xfrm>
+            <a:off x="10332720" y="3749040"/>
+            <a:ext cx="320040" cy="320040"/>
+          </a:xfrm>
+          <a:prstGeom prst="rect">
+            <a:avLst/>
+          </a:prstGeom>
+          <a:solidFill>
+            <a:srgbClr val="E3B18D"/>
+          </a:solidFill>
+          <a:ln>
+            <a:noFill/>
+          </a:ln>
+        </p:spPr>
+        <p:txBody>
+          <a:bodyPr/>
+          <a:lstStyle/>
+          <a:p>
+            <a:endParaRPr lang="pl-PL"/>
+          </a:p>
+        </p:txBody>
+      </p:sp>
+      <p:sp>
+        <p:nvSpPr>
+          <p:cNvPr id="123" name="Element 123"/>
+          <p:cNvSpPr/>
+          <p:nvPr/>
+        </p:nvSpPr>
+        <p:spPr>
+          <a:xfrm>
+            <a:off x="10698480" y="3749040"/>
+            <a:ext cx="320040" cy="320040"/>
+          </a:xfrm>
+          <a:prstGeom prst="rect">
+            <a:avLst/>
+          </a:prstGeom>
+          <a:solidFill>
+            <a:srgbClr val="404040"/>
+          </a:solidFill>
+          <a:ln>
+            <a:noFill/>
+          </a:ln>
+        </p:spPr>
+        <p:txBody>
+          <a:bodyPr/>
+          <a:lstStyle/>
+          <a:p>
+            <a:endParaRPr lang="pl-PL"/>
+          </a:p>
+        </p:txBody>
+      </p:sp>
+      <p:sp>
+        <p:nvSpPr>
+          <p:cNvPr id="124" name="Element 124"/>
+          <p:cNvSpPr/>
+          <p:nvPr/>
+        </p:nvSpPr>
+        <p:spPr>
+          <a:xfrm>
+            <a:off x="11064240" y="3749040"/>
+            <a:ext cx="320040" cy="320040"/>
+          </a:xfrm>
+          <a:prstGeom prst="rect">
+            <a:avLst/>
+          </a:prstGeom>
+          <a:solidFill>
+            <a:srgbClr val="C9CDD2"/>
+          </a:solidFill>
+          <a:ln>
+            <a:noFill/>
+          </a:ln>
+        </p:spPr>
+        <p:txBody>
+          <a:bodyPr/>
+          <a:lstStyle/>
+          <a:p>
+            <a:endParaRPr lang="pl-PL"/>
+          </a:p>
+        </p:txBody>
+      </p:sp>
+      <p:sp>
+        <p:nvSpPr>
+          <p:cNvPr id="125" name="Element 125"/>
+          <p:cNvSpPr/>
+          <p:nvPr/>
+        </p:nvSpPr>
+        <p:spPr>
+          <a:xfrm>
+            <a:off x="6126480" y="4297680"/>
+            <a:ext cx="5303520" cy="365760"/>
+          </a:xfrm>
+          <a:prstGeom prst="rect">
+            <a:avLst/>
+          </a:prstGeom>
+          <a:noFill/>
+          <a:ln>
+            <a:noFill/>
+          </a:ln>
+        </p:spPr>
+        <p:txBody>
+          <a:bodyPr wrap="square" lIns="0" tIns="0" rIns="0" bIns="0" anchor="ctr">
+            <a:noAutofit/>
+          </a:bodyPr>
+          <a:lstStyle/>
+          <a:p>
+            <a:pPr algn="l"/>
+            <a:r>
+              <a:rPr lang="pl-PL" sz="1400" b="0" dirty="0">
+                <a:solidFill>
+                  <a:srgbClr val="8A8A8A"/>
+                </a:solidFill>
+                <a:latin typeface="+mn-lt"/>
+              </a:rPr>
+              <a:t>to samo światło, ta sama paleta, ta sama kompozycja</a:t>
+            </a:r>
           </a:p>
         </p:txBody>
       </p:sp>
@@ -22273,42 +25788,88 @@
           <a:bodyPr/>
           <a:lstStyle/>
           <a:p>
+            <a:pPr>
+              <a:spcBef>
+                <a:spcPts val="600"/>
+              </a:spcBef>
+            </a:pPr>
             <a:r>
               <a:rPr lang="pl-PL" dirty="0"/>
               <a:t>Teoria światła i ekspozycji</a:t>
             </a:r>
           </a:p>
           <a:p>
+            <a:pPr>
+              <a:spcBef>
+                <a:spcPts val="600"/>
+              </a:spcBef>
+            </a:pPr>
             <a:r>
               <a:rPr lang="pl-PL" dirty="0"/>
               <a:t>Praktyka podstawowa</a:t>
             </a:r>
           </a:p>
           <a:p>
+            <a:pPr>
+              <a:spcBef>
+                <a:spcPts val="600"/>
+              </a:spcBef>
+            </a:pPr>
             <a:r>
               <a:rPr lang="pl-PL" dirty="0"/>
               <a:t>Zaawansowane setupy</a:t>
             </a:r>
           </a:p>
           <a:p>
+            <a:pPr>
+              <a:spcBef>
+                <a:spcPts val="600"/>
+              </a:spcBef>
+            </a:pPr>
+            <a:r>
+              <a:rPr lang="pl-PL" dirty="0"/>
+              <a:t>13:00 — przerwa obiadowa</a:t>
+            </a:r>
+          </a:p>
+          <a:p>
+            <a:pPr>
+              <a:spcBef>
+                <a:spcPts val="600"/>
+              </a:spcBef>
+            </a:pPr>
             <a:r>
               <a:rPr lang="pl-PL" dirty="0"/>
               <a:t>Fotografia produktu</a:t>
             </a:r>
           </a:p>
           <a:p>
+            <a:pPr>
+              <a:spcBef>
+                <a:spcPts val="600"/>
+              </a:spcBef>
+            </a:pPr>
             <a:r>
               <a:rPr lang="pl-PL" dirty="0"/>
               <a:t>Setupy studyjne</a:t>
             </a:r>
           </a:p>
           <a:p>
+            <a:pPr>
+              <a:spcBef>
+                <a:spcPts val="600"/>
+              </a:spcBef>
+            </a:pPr>
             <a:r>
               <a:rPr lang="pl-PL" dirty="0"/>
               <a:t>LAB i własne ćwiczenia</a:t>
             </a:r>
           </a:p>
           <a:p>
+            <a:pPr>
+              <a:spcBef>
+                <a:spcPts val="600"/>
+              </a:spcBef>
+            </a:pPr>
             <a:r>
               <a:rPr lang="pl-PL" dirty="0"/>
               <a:t>Podsumowanie</a:t>
@@ -22383,8 +25944,8 @@
         </p:nvCxnSpPr>
         <p:spPr>
           <a:xfrm flipV="1">
-            <a:off x="5852160" y="3291840"/>
-            <a:ext cx="367519" cy="1188720"/>
+            <a:off x="5852160" y="3449027"/>
+            <a:ext cx="271662" cy="1031533"/>
           </a:xfrm>
           <a:prstGeom prst="line">
             <a:avLst/>
@@ -22404,8 +25965,8 @@
         </p:nvCxnSpPr>
         <p:spPr>
           <a:xfrm flipV="1">
-            <a:off x="6219679" y="2421637"/>
-            <a:ext cx="1004081" cy="870203"/>
+            <a:off x="6123822" y="2621803"/>
+            <a:ext cx="761181" cy="827225"/>
           </a:xfrm>
           <a:prstGeom prst="line">
             <a:avLst/>
@@ -22425,8 +25986,8 @@
         </p:nvCxnSpPr>
         <p:spPr>
           <a:xfrm flipV="1">
-            <a:off x="7223760" y="2103120"/>
-            <a:ext cx="1371600" cy="318517"/>
+            <a:off x="6885003" y="2162727"/>
+            <a:ext cx="1099938" cy="459075"/>
           </a:xfrm>
           <a:prstGeom prst="line">
             <a:avLst/>
@@ -22446,8 +26007,8 @@
         </p:nvCxnSpPr>
         <p:spPr>
           <a:xfrm>
-            <a:off x="8595360" y="2103120"/>
-            <a:ext cx="1371600" cy="318517"/>
+            <a:off x="7984941" y="2162727"/>
+            <a:ext cx="1220839" cy="0"/>
           </a:xfrm>
           <a:prstGeom prst="line">
             <a:avLst/>
@@ -22467,8 +26028,8 @@
         </p:nvCxnSpPr>
         <p:spPr>
           <a:xfrm>
-            <a:off x="9966960" y="2421637"/>
-            <a:ext cx="1004081" cy="870203"/>
+            <a:off x="9205779" y="2162727"/>
+            <a:ext cx="1099938" cy="459075"/>
           </a:xfrm>
           <a:prstGeom prst="line">
             <a:avLst/>
@@ -22488,8 +26049,8 @@
         </p:nvCxnSpPr>
         <p:spPr>
           <a:xfrm>
-            <a:off x="10971041" y="3291840"/>
-            <a:ext cx="367519" cy="1188720"/>
+            <a:off x="10305717" y="2621803"/>
+            <a:ext cx="761181" cy="827225"/>
           </a:xfrm>
           <a:prstGeom prst="line">
             <a:avLst/>
@@ -22501,9 +26062,30 @@
           </a:ln>
         </p:spPr>
       </p:cxnSp>
-      <p:sp>
-        <p:nvSpPr>
-          <p:cNvPr id="107" name="Element 107"/>
+      <p:cxnSp>
+        <p:nvCxnSpPr>
+          <p:cNvPr id="107" name="Linia 107"/>
+          <p:cNvCxnSpPr/>
+          <p:nvPr/>
+        </p:nvCxnSpPr>
+        <p:spPr>
+          <a:xfrm>
+            <a:off x="11066898" y="3449027"/>
+            <a:ext cx="271662" cy="1031533"/>
+          </a:xfrm>
+          <a:prstGeom prst="line">
+            <a:avLst/>
+          </a:prstGeom>
+          <a:ln w="19050">
+            <a:solidFill>
+              <a:srgbClr val="E3B18D"/>
+            </a:solidFill>
+          </a:ln>
+        </p:spPr>
+      </p:cxnSp>
+      <p:sp>
+        <p:nvSpPr>
+          <p:cNvPr id="108" name="Element 108"/>
           <p:cNvSpPr/>
           <p:nvPr/>
         </p:nvSpPr>
@@ -22545,13 +26127,13 @@
       </p:sp>
       <p:sp>
         <p:nvSpPr>
-          <p:cNvPr id="108" name="Element 108"/>
+          <p:cNvPr id="109" name="Element 109"/>
           <p:cNvSpPr/>
           <p:nvPr/>
         </p:nvSpPr>
         <p:spPr>
           <a:xfrm>
-            <a:off x="5945359" y="3017520"/>
+            <a:off x="5849502" y="3174707"/>
             <a:ext cx="548640" cy="548640"/>
           </a:xfrm>
           <a:prstGeom prst="ellipse">
@@ -22587,13 +26169,13 @@
       </p:sp>
       <p:sp>
         <p:nvSpPr>
-          <p:cNvPr id="109" name="Element 109"/>
+          <p:cNvPr id="110" name="Element 110"/>
           <p:cNvSpPr/>
           <p:nvPr/>
         </p:nvSpPr>
         <p:spPr>
           <a:xfrm>
-            <a:off x="6949440" y="2147317"/>
+            <a:off x="6610683" y="2347483"/>
             <a:ext cx="548640" cy="548640"/>
           </a:xfrm>
           <a:prstGeom prst="ellipse">
@@ -22629,13 +26211,53 @@
       </p:sp>
       <p:sp>
         <p:nvSpPr>
-          <p:cNvPr id="110" name="Element 110"/>
+          <p:cNvPr id="111" name="Element 111"/>
           <p:cNvSpPr/>
           <p:nvPr/>
         </p:nvSpPr>
         <p:spPr>
           <a:xfrm>
-            <a:off x="8321040" y="1828800"/>
+            <a:off x="7600893" y="1778679"/>
+            <a:ext cx="768096" cy="768096"/>
+          </a:xfrm>
+          <a:prstGeom prst="ellipse">
+            <a:avLst/>
+          </a:prstGeom>
+          <a:solidFill>
+            <a:srgbClr val="E3B18D"/>
+          </a:solidFill>
+          <a:ln>
+            <a:noFill/>
+          </a:ln>
+        </p:spPr>
+        <p:txBody>
+          <a:bodyPr wrap="square" lIns="0" tIns="0" rIns="0" bIns="0" anchor="ctr">
+            <a:noAutofit/>
+          </a:bodyPr>
+          <a:lstStyle/>
+          <a:p>
+            <a:pPr algn="ctr"/>
+            <a:r>
+              <a:rPr lang="pl-PL" sz="1200" b="1" dirty="0">
+                <a:solidFill>
+                  <a:srgbClr val="FFFFFF"/>
+                </a:solidFill>
+                <a:latin typeface="+mn-lt"/>
+              </a:rPr>
+              <a:t>obiad</a:t>
+            </a:r>
+          </a:p>
+        </p:txBody>
+      </p:sp>
+      <p:sp>
+        <p:nvSpPr>
+          <p:cNvPr id="112" name="Element 112"/>
+          <p:cNvSpPr/>
+          <p:nvPr/>
+        </p:nvSpPr>
+        <p:spPr>
+          <a:xfrm>
+            <a:off x="8931459" y="1888407"/>
             <a:ext cx="548640" cy="548640"/>
           </a:xfrm>
           <a:prstGeom prst="ellipse">
@@ -22671,13 +26293,13 @@
       </p:sp>
       <p:sp>
         <p:nvSpPr>
-          <p:cNvPr id="111" name="Element 111"/>
+          <p:cNvPr id="113" name="Element 113"/>
           <p:cNvSpPr/>
           <p:nvPr/>
         </p:nvSpPr>
         <p:spPr>
           <a:xfrm>
-            <a:off x="9692640" y="2147317"/>
+            <a:off x="10031397" y="2347483"/>
             <a:ext cx="548640" cy="548640"/>
           </a:xfrm>
           <a:prstGeom prst="ellipse">
@@ -22713,13 +26335,13 @@
       </p:sp>
       <p:sp>
         <p:nvSpPr>
-          <p:cNvPr id="112" name="Element 112"/>
+          <p:cNvPr id="114" name="Element 114"/>
           <p:cNvSpPr/>
           <p:nvPr/>
         </p:nvSpPr>
         <p:spPr>
           <a:xfrm>
-            <a:off x="10696721" y="3017520"/>
+            <a:off x="10792578" y="3174707"/>
             <a:ext cx="548640" cy="548640"/>
           </a:xfrm>
           <a:prstGeom prst="ellipse">
@@ -22755,7 +26377,7 @@
       </p:sp>
       <p:sp>
         <p:nvSpPr>
-          <p:cNvPr id="113" name="Element 113"/>
+          <p:cNvPr id="115" name="Element 115"/>
           <p:cNvSpPr/>
           <p:nvPr/>
         </p:nvSpPr>
@@ -22797,7 +26419,7 @@
       </p:sp>
       <p:sp>
         <p:nvSpPr>
-          <p:cNvPr id="114" name="Element 114"/>
+          <p:cNvPr id="116" name="Element 116"/>
           <p:cNvSpPr/>
           <p:nvPr/>
         </p:nvSpPr>
@@ -22835,7 +26457,7 @@
       </p:sp>
       <p:sp>
         <p:nvSpPr>
-          <p:cNvPr id="115" name="Element 115"/>
+          <p:cNvPr id="117" name="Element 117"/>
           <p:cNvSpPr/>
           <p:nvPr/>
         </p:nvSpPr>
@@ -22866,21 +26488,21 @@
                 </a:solidFill>
                 <a:latin typeface="+mn-lt"/>
               </a:rPr>
-              <a:t>17:50</a:t>
-            </a:r>
-          </a:p>
-        </p:txBody>
-      </p:sp>
-      <p:sp>
-        <p:nvSpPr>
-          <p:cNvPr id="116" name="Element 116"/>
+              <a:t>17:20</a:t>
+            </a:r>
+          </a:p>
+        </p:txBody>
+      </p:sp>
+      <p:sp>
+        <p:nvSpPr>
+          <p:cNvPr id="118" name="Element 118"/>
           <p:cNvSpPr/>
           <p:nvPr/>
         </p:nvSpPr>
         <p:spPr>
           <a:xfrm>
-            <a:off x="7223760" y="3383280"/>
-            <a:ext cx="2743200" cy="457200"/>
+            <a:off x="7253421" y="2619927"/>
+            <a:ext cx="1463040" cy="365760"/>
           </a:xfrm>
           <a:prstGeom prst="rect">
             <a:avLst/>
@@ -22898,13 +26520,51 @@
           <a:p>
             <a:pPr algn="ctr"/>
             <a:r>
-              <a:rPr lang="pl-PL" sz="1800" b="0" dirty="0">
+              <a:rPr lang="pl-PL" sz="1600" b="0" dirty="0">
                 <a:solidFill>
                   <a:srgbClr val="8A8A8A"/>
                 </a:solidFill>
                 <a:latin typeface="+mn-lt"/>
               </a:rPr>
-              <a:t>cały dzień, 7 bloków</a:t>
+              <a:t>13:00</a:t>
+            </a:r>
+          </a:p>
+        </p:txBody>
+      </p:sp>
+      <p:sp>
+        <p:nvSpPr>
+          <p:cNvPr id="119" name="Element 119"/>
+          <p:cNvSpPr/>
+          <p:nvPr/>
+        </p:nvSpPr>
+        <p:spPr>
+          <a:xfrm>
+            <a:off x="7223760" y="3383280"/>
+            <a:ext cx="2743200" cy="457200"/>
+          </a:xfrm>
+          <a:prstGeom prst="rect">
+            <a:avLst/>
+          </a:prstGeom>
+          <a:noFill/>
+          <a:ln>
+            <a:noFill/>
+          </a:ln>
+        </p:spPr>
+        <p:txBody>
+          <a:bodyPr wrap="square" lIns="0" tIns="0" rIns="0" bIns="0" anchor="ctr">
+            <a:noAutofit/>
+          </a:bodyPr>
+          <a:lstStyle/>
+          <a:p>
+            <a:pPr algn="ctr"/>
+            <a:r>
+              <a:rPr lang="pl-PL" sz="1800" b="0" dirty="0">
+                <a:solidFill>
+                  <a:srgbClr val="8A8A8A"/>
+                </a:solidFill>
+                <a:latin typeface="+mn-lt"/>
+              </a:rPr>
+              <a:t>9:00 – 17:20</a:t>
             </a:r>
           </a:p>
         </p:txBody>
@@ -23075,6 +26735,359 @@
               <a:t>4</a:t>
             </a:fld>
             <a:endParaRPr lang="pl-PL" noProof="0"/>
+          </a:p>
+        </p:txBody>
+      </p:sp>
+      <p:cxnSp>
+        <p:nvCxnSpPr>
+          <p:cNvPr id="101" name="Linia 101"/>
+          <p:cNvCxnSpPr/>
+          <p:nvPr/>
+        </p:nvCxnSpPr>
+        <p:spPr>
+          <a:xfrm>
+            <a:off x="8595360" y="1691640"/>
+            <a:ext cx="1652328" cy="1200486"/>
+          </a:xfrm>
+          <a:prstGeom prst="line">
+            <a:avLst/>
+          </a:prstGeom>
+          <a:ln w="19050">
+            <a:solidFill>
+              <a:srgbClr val="E3B18D"/>
+            </a:solidFill>
+          </a:ln>
+        </p:spPr>
+      </p:cxnSp>
+      <p:cxnSp>
+        <p:nvCxnSpPr>
+          <p:cNvPr id="102" name="Linia 102"/>
+          <p:cNvCxnSpPr/>
+          <p:nvPr/>
+        </p:nvCxnSpPr>
+        <p:spPr>
+          <a:xfrm flipV="1">
+            <a:off x="9616555" y="2892126"/>
+            <a:ext cx="631133" cy="1942428"/>
+          </a:xfrm>
+          <a:prstGeom prst="line">
+            <a:avLst/>
+          </a:prstGeom>
+          <a:ln w="19050">
+            <a:solidFill>
+              <a:srgbClr val="E3B18D"/>
+            </a:solidFill>
+          </a:ln>
+        </p:spPr>
+      </p:cxnSp>
+      <p:cxnSp>
+        <p:nvCxnSpPr>
+          <p:cNvPr id="103" name="Linia 103"/>
+          <p:cNvCxnSpPr/>
+          <p:nvPr/>
+        </p:nvCxnSpPr>
+        <p:spPr>
+          <a:xfrm>
+            <a:off x="7574165" y="4834554"/>
+            <a:ext cx="2042389" cy="0"/>
+          </a:xfrm>
+          <a:prstGeom prst="line">
+            <a:avLst/>
+          </a:prstGeom>
+          <a:ln w="19050">
+            <a:solidFill>
+              <a:srgbClr val="E3B18D"/>
+            </a:solidFill>
+          </a:ln>
+        </p:spPr>
+      </p:cxnSp>
+      <p:cxnSp>
+        <p:nvCxnSpPr>
+          <p:cNvPr id="104" name="Linia 104"/>
+          <p:cNvCxnSpPr/>
+          <p:nvPr/>
+        </p:nvCxnSpPr>
+        <p:spPr>
+          <a:xfrm>
+            <a:off x="6943032" y="2892126"/>
+            <a:ext cx="631133" cy="1942428"/>
+          </a:xfrm>
+          <a:prstGeom prst="line">
+            <a:avLst/>
+          </a:prstGeom>
+          <a:ln w="19050">
+            <a:solidFill>
+              <a:srgbClr val="E3B18D"/>
+            </a:solidFill>
+          </a:ln>
+        </p:spPr>
+      </p:cxnSp>
+      <p:cxnSp>
+        <p:nvCxnSpPr>
+          <p:cNvPr id="105" name="Linia 105"/>
+          <p:cNvCxnSpPr/>
+          <p:nvPr/>
+        </p:nvCxnSpPr>
+        <p:spPr>
+          <a:xfrm flipV="1">
+            <a:off x="6943032" y="1691640"/>
+            <a:ext cx="1652328" cy="1200486"/>
+          </a:xfrm>
+          <a:prstGeom prst="line">
+            <a:avLst/>
+          </a:prstGeom>
+          <a:ln w="19050">
+            <a:solidFill>
+              <a:srgbClr val="E3B18D"/>
+            </a:solidFill>
+          </a:ln>
+        </p:spPr>
+      </p:cxnSp>
+      <p:sp>
+        <p:nvSpPr>
+          <p:cNvPr id="106" name="Element 106"/>
+          <p:cNvSpPr/>
+          <p:nvPr/>
+        </p:nvSpPr>
+        <p:spPr>
+          <a:xfrm>
+            <a:off x="8275320" y="1371600"/>
+            <a:ext cx="640080" cy="640080"/>
+          </a:xfrm>
+          <a:prstGeom prst="ellipse">
+            <a:avLst/>
+          </a:prstGeom>
+          <a:solidFill>
+            <a:srgbClr val="FFFFFF"/>
+          </a:solidFill>
+          <a:ln w="19050">
+            <a:solidFill>
+              <a:srgbClr val="404040"/>
+            </a:solidFill>
+          </a:ln>
+        </p:spPr>
+        <p:txBody>
+          <a:bodyPr wrap="square" lIns="0" tIns="0" rIns="0" bIns="0" anchor="ctr">
+            <a:noAutofit/>
+          </a:bodyPr>
+          <a:lstStyle/>
+          <a:p>
+            <a:pPr algn="ctr"/>
+            <a:r>
+              <a:rPr lang="pl-PL" sz="1800" b="1" dirty="0">
+                <a:solidFill>
+                  <a:srgbClr val="404040"/>
+                </a:solidFill>
+                <a:latin typeface="+mn-lt"/>
+              </a:rPr>
+              <a:t>1</a:t>
+            </a:r>
+          </a:p>
+        </p:txBody>
+      </p:sp>
+      <p:sp>
+        <p:nvSpPr>
+          <p:cNvPr id="107" name="Element 107"/>
+          <p:cNvSpPr/>
+          <p:nvPr/>
+        </p:nvSpPr>
+        <p:spPr>
+          <a:xfrm>
+            <a:off x="9927648" y="2572086"/>
+            <a:ext cx="640080" cy="640080"/>
+          </a:xfrm>
+          <a:prstGeom prst="ellipse">
+            <a:avLst/>
+          </a:prstGeom>
+          <a:solidFill>
+            <a:srgbClr val="FFFFFF"/>
+          </a:solidFill>
+          <a:ln w="19050">
+            <a:solidFill>
+              <a:srgbClr val="404040"/>
+            </a:solidFill>
+          </a:ln>
+        </p:spPr>
+        <p:txBody>
+          <a:bodyPr wrap="square" lIns="0" tIns="0" rIns="0" bIns="0" anchor="ctr">
+            <a:noAutofit/>
+          </a:bodyPr>
+          <a:lstStyle/>
+          <a:p>
+            <a:pPr algn="ctr"/>
+            <a:r>
+              <a:rPr lang="pl-PL" sz="1800" b="1" dirty="0">
+                <a:solidFill>
+                  <a:srgbClr val="404040"/>
+                </a:solidFill>
+                <a:latin typeface="+mn-lt"/>
+              </a:rPr>
+              <a:t>2</a:t>
+            </a:r>
+          </a:p>
+        </p:txBody>
+      </p:sp>
+      <p:sp>
+        <p:nvSpPr>
+          <p:cNvPr id="108" name="Element 108"/>
+          <p:cNvSpPr/>
+          <p:nvPr/>
+        </p:nvSpPr>
+        <p:spPr>
+          <a:xfrm>
+            <a:off x="9296515" y="4514514"/>
+            <a:ext cx="640080" cy="640080"/>
+          </a:xfrm>
+          <a:prstGeom prst="ellipse">
+            <a:avLst/>
+          </a:prstGeom>
+          <a:solidFill>
+            <a:srgbClr val="FFFFFF"/>
+          </a:solidFill>
+          <a:ln w="19050">
+            <a:solidFill>
+              <a:srgbClr val="404040"/>
+            </a:solidFill>
+          </a:ln>
+        </p:spPr>
+        <p:txBody>
+          <a:bodyPr wrap="square" lIns="0" tIns="0" rIns="0" bIns="0" anchor="ctr">
+            <a:noAutofit/>
+          </a:bodyPr>
+          <a:lstStyle/>
+          <a:p>
+            <a:pPr algn="ctr"/>
+            <a:r>
+              <a:rPr lang="pl-PL" sz="1800" b="1" dirty="0">
+                <a:solidFill>
+                  <a:srgbClr val="404040"/>
+                </a:solidFill>
+                <a:latin typeface="+mn-lt"/>
+              </a:rPr>
+              <a:t>3</a:t>
+            </a:r>
+          </a:p>
+        </p:txBody>
+      </p:sp>
+      <p:sp>
+        <p:nvSpPr>
+          <p:cNvPr id="109" name="Element 109"/>
+          <p:cNvSpPr/>
+          <p:nvPr/>
+        </p:nvSpPr>
+        <p:spPr>
+          <a:xfrm>
+            <a:off x="7254125" y="4514514"/>
+            <a:ext cx="640080" cy="640080"/>
+          </a:xfrm>
+          <a:prstGeom prst="ellipse">
+            <a:avLst/>
+          </a:prstGeom>
+          <a:solidFill>
+            <a:srgbClr val="FFFFFF"/>
+          </a:solidFill>
+          <a:ln w="19050">
+            <a:solidFill>
+              <a:srgbClr val="404040"/>
+            </a:solidFill>
+          </a:ln>
+        </p:spPr>
+        <p:txBody>
+          <a:bodyPr wrap="square" lIns="0" tIns="0" rIns="0" bIns="0" anchor="ctr">
+            <a:noAutofit/>
+          </a:bodyPr>
+          <a:lstStyle/>
+          <a:p>
+            <a:pPr algn="ctr"/>
+            <a:r>
+              <a:rPr lang="pl-PL" sz="1800" b="1" dirty="0">
+                <a:solidFill>
+                  <a:srgbClr val="404040"/>
+                </a:solidFill>
+                <a:latin typeface="+mn-lt"/>
+              </a:rPr>
+              <a:t>4</a:t>
+            </a:r>
+          </a:p>
+        </p:txBody>
+      </p:sp>
+      <p:sp>
+        <p:nvSpPr>
+          <p:cNvPr id="110" name="Element 110"/>
+          <p:cNvSpPr/>
+          <p:nvPr/>
+        </p:nvSpPr>
+        <p:spPr>
+          <a:xfrm>
+            <a:off x="6622992" y="2572086"/>
+            <a:ext cx="640080" cy="640080"/>
+          </a:xfrm>
+          <a:prstGeom prst="ellipse">
+            <a:avLst/>
+          </a:prstGeom>
+          <a:solidFill>
+            <a:srgbClr val="FFFFFF"/>
+          </a:solidFill>
+          <a:ln w="19050">
+            <a:solidFill>
+              <a:srgbClr val="404040"/>
+            </a:solidFill>
+          </a:ln>
+        </p:spPr>
+        <p:txBody>
+          <a:bodyPr wrap="square" lIns="0" tIns="0" rIns="0" bIns="0" anchor="ctr">
+            <a:noAutofit/>
+          </a:bodyPr>
+          <a:lstStyle/>
+          <a:p>
+            <a:pPr algn="ctr"/>
+            <a:r>
+              <a:rPr lang="pl-PL" sz="1800" b="1" dirty="0">
+                <a:solidFill>
+                  <a:srgbClr val="404040"/>
+                </a:solidFill>
+                <a:latin typeface="+mn-lt"/>
+              </a:rPr>
+              <a:t>5</a:t>
+            </a:r>
+          </a:p>
+        </p:txBody>
+      </p:sp>
+      <p:sp>
+        <p:nvSpPr>
+          <p:cNvPr id="111" name="Element 111"/>
+          <p:cNvSpPr/>
+          <p:nvPr/>
+        </p:nvSpPr>
+        <p:spPr>
+          <a:xfrm>
+            <a:off x="7680960" y="3200400"/>
+            <a:ext cx="1828800" cy="457200"/>
+          </a:xfrm>
+          <a:prstGeom prst="rect">
+            <a:avLst/>
+          </a:prstGeom>
+          <a:noFill/>
+          <a:ln>
+            <a:noFill/>
+          </a:ln>
+        </p:spPr>
+        <p:txBody>
+          <a:bodyPr wrap="square" lIns="0" tIns="0" rIns="0" bIns="0" anchor="ctr">
+            <a:noAutofit/>
+          </a:bodyPr>
+          <a:lstStyle/>
+          <a:p>
+            <a:pPr algn="ctr"/>
+            <a:r>
+              <a:rPr lang="pl-PL" sz="1800" b="0" dirty="0">
+                <a:solidFill>
+                  <a:srgbClr val="8A8A8A"/>
+                </a:solidFill>
+                <a:latin typeface="+mn-lt"/>
+              </a:rPr>
+              <a:t>proces</a:t>
+            </a:r>
           </a:p>
         </p:txBody>
       </p:sp>

</xml_diff>